<commit_message>
Switch lecture decks to Noto Serif KR Black
Co-Authored-By: Claude Opus 5.5 <noreply@anthropic.com>
Claude-Session: https://claude.ai/code/session_011L3sm83vPfAuzHdbV1bgYe
</commit_message>
<xml_diff>
--- a/ppt/out/WLC2급_제01강_죽음을이해하는통찰.pptx
+++ b/ppt/out/WLC2급_제01강_죽음을이해하는통찰.pptx
@@ -164,7 +164,7 @@
   <p:extLst>
     <p:ext uri="{521415D9-36F7-43E2-AB2F-B90AF26B5E84}">
       <p14:sectionLst xmlns:p14="http://schemas.microsoft.com/office/powerpoint/2010/main">
-        <p14:section name="열기" id="{e6a902d2-5356-7c62-56e9-e9554fdd9dd3}">
+        <p14:section name="열기" id="{bf24678e-e1b9-ed97-f856-f808f01a28af}">
           <p14:sldIdLst>
             <p14:sldId id="256"/>
             <p14:sldId id="257"/>
@@ -176,7 +176,7 @@
             <p14:sldId id="263"/>
           </p14:sldIdLst>
         </p14:section>
-        <p14:section name="1교시 죽음을 여러 눈으로" id="{e9768948-5d73-ec1f-b438-47245d83b259}">
+        <p14:section name="1교시 죽음을 여러 눈으로" id="{82d36adc-cf77-a41e-64e9-5cff614fb769}">
           <p14:sldIdLst>
             <p14:sldId id="264"/>
             <p14:sldId id="265"/>
@@ -191,7 +191,7 @@
             <p14:sldId id="274"/>
           </p14:sldIdLst>
         </p14:section>
-        <p14:section name="2교시 두려움과 경계" id="{1ad6e6a2-25b4-1f42-fad9-15c8bb0eeaa2}">
+        <p14:section name="2교시 두려움과 경계" id="{ccc56e31-d532-7b1d-aed9-415cf2be3204}">
           <p14:sldIdLst>
             <p14:sldId id="275"/>
             <p14:sldId id="276"/>
@@ -211,7 +211,7 @@
             <p14:sldId id="290"/>
           </p14:sldIdLst>
         </p14:section>
-        <p14:section name="3교시 통찰을 삶으로" id="{c563a981-1c6d-fda7-eb19-8a2d200fd937}">
+        <p14:section name="3교시 통찰을 삶으로" id="{da2facea-60be-09ab-6d53-acf6ce2967d7}">
           <p14:sldIdLst>
             <p14:sldId id="291"/>
             <p14:sldId id="292"/>
@@ -232,7 +232,7 @@
             <p14:sldId id="307"/>
           </p14:sldIdLst>
         </p14:section>
-        <p14:section name="정리와 예고" id="{ae23a7a3-50e1-c5fb-09dc-a7a0a8f3d3ee}">
+        <p14:section name="정리와 예고" id="{d8d13f19-3cf7-5825-b895-462a05d5a79e}">
           <p14:sldIdLst>
             <p14:sldId id="308"/>
             <p14:sldId id="309"/>
@@ -6986,9 +6986,9 @@
                 <a:solidFill>
                   <a:srgbClr val="FFFFFF"/>
                 </a:solidFill>
-                <a:latin typeface="Malgun Gothic" pitchFamily="34" charset="0"/>
-                <a:ea typeface="Malgun Gothic" pitchFamily="34" charset="-122"/>
-                <a:cs typeface="Malgun Gothic" pitchFamily="34" charset="-120"/>
+                <a:latin typeface="Noto Serif KR Black" pitchFamily="34" charset="0"/>
+                <a:ea typeface="Noto Serif KR Black" pitchFamily="34" charset="-122"/>
+                <a:cs typeface="Noto Serif KR Black" pitchFamily="34" charset="-120"/>
               </a:rPr>
               <a:t>죽음을 이해하는 통찰</a:t>
             </a:r>
@@ -9326,16 +9326,16 @@
                           <a:solidFill>
                             <a:srgbClr val="FFFFFF"/>
                           </a:solidFill>
-                          <a:latin typeface="Malgun Gothic" pitchFamily="34" charset="0"/>
-                          <a:ea typeface="Malgun Gothic" pitchFamily="34" charset="-122"/>
-                          <a:cs typeface="Malgun Gothic" pitchFamily="34" charset="-120"/>
+                          <a:latin typeface="Noto Serif KR Black" pitchFamily="34" charset="0"/>
+                          <a:ea typeface="Noto Serif KR Black" pitchFamily="34" charset="-122"/>
+                          <a:cs typeface="Noto Serif KR Black" pitchFamily="34" charset="-120"/>
                         </a:rPr>
                         <a:t>구분</a:t>
                       </a:r>
                       <a:endParaRPr lang="en-US" sz="1800" dirty="0">
-                        <a:latin typeface="Malgun Gothic" charset="0"/>
-                        <a:ea typeface="Malgun Gothic" charset="0"/>
-                        <a:cs typeface="Malgun Gothic" charset="0"/>
+                        <a:latin typeface="Noto Serif KR Black" charset="0"/>
+                        <a:ea typeface="Noto Serif KR Black" charset="0"/>
+                        <a:cs typeface="Noto Serif KR Black" charset="0"/>
                       </a:endParaRPr>
                     </a:p>
                   </a:txBody>
@@ -9394,16 +9394,16 @@
                           <a:solidFill>
                             <a:srgbClr val="FFFFFF"/>
                           </a:solidFill>
-                          <a:latin typeface="Malgun Gothic" pitchFamily="34" charset="0"/>
-                          <a:ea typeface="Malgun Gothic" pitchFamily="34" charset="-122"/>
-                          <a:cs typeface="Malgun Gothic" pitchFamily="34" charset="-120"/>
+                          <a:latin typeface="Noto Serif KR Black" pitchFamily="34" charset="0"/>
+                          <a:ea typeface="Noto Serif KR Black" pitchFamily="34" charset="-122"/>
+                          <a:cs typeface="Noto Serif KR Black" pitchFamily="34" charset="-120"/>
                         </a:rPr>
                         <a:t>핵심 개념</a:t>
                       </a:r>
                       <a:endParaRPr lang="en-US" sz="1800" dirty="0">
-                        <a:latin typeface="Malgun Gothic" charset="0"/>
-                        <a:ea typeface="Malgun Gothic" charset="0"/>
-                        <a:cs typeface="Malgun Gothic" charset="0"/>
+                        <a:latin typeface="Noto Serif KR Black" charset="0"/>
+                        <a:ea typeface="Noto Serif KR Black" charset="0"/>
+                        <a:cs typeface="Noto Serif KR Black" charset="0"/>
                       </a:endParaRPr>
                     </a:p>
                   </a:txBody>
@@ -9462,16 +9462,16 @@
                           <a:solidFill>
                             <a:srgbClr val="FFFFFF"/>
                           </a:solidFill>
-                          <a:latin typeface="Malgun Gothic" pitchFamily="34" charset="0"/>
-                          <a:ea typeface="Malgun Gothic" pitchFamily="34" charset="-122"/>
-                          <a:cs typeface="Malgun Gothic" pitchFamily="34" charset="-120"/>
+                          <a:latin typeface="Noto Serif KR Black" pitchFamily="34" charset="0"/>
+                          <a:ea typeface="Noto Serif KR Black" pitchFamily="34" charset="-122"/>
+                          <a:cs typeface="Noto Serif KR Black" pitchFamily="34" charset="-120"/>
                         </a:rPr>
                         <a:t>WLC가 이해할 점</a:t>
                       </a:r>
                       <a:endParaRPr lang="en-US" sz="1800" dirty="0">
-                        <a:latin typeface="Malgun Gothic" charset="0"/>
-                        <a:ea typeface="Malgun Gothic" charset="0"/>
-                        <a:cs typeface="Malgun Gothic" charset="0"/>
+                        <a:latin typeface="Noto Serif KR Black" charset="0"/>
+                        <a:ea typeface="Noto Serif KR Black" charset="0"/>
+                        <a:cs typeface="Noto Serif KR Black" charset="0"/>
                       </a:endParaRPr>
                     </a:p>
                   </a:txBody>
@@ -9532,16 +9532,16 @@
                           <a:solidFill>
                             <a:srgbClr val="1F4E4A"/>
                           </a:solidFill>
-                          <a:latin typeface="Malgun Gothic" pitchFamily="34" charset="0"/>
-                          <a:ea typeface="Malgun Gothic" pitchFamily="34" charset="-122"/>
-                          <a:cs typeface="Malgun Gothic" pitchFamily="34" charset="-120"/>
+                          <a:latin typeface="Noto Serif KR Black" pitchFamily="34" charset="0"/>
+                          <a:ea typeface="Noto Serif KR Black" pitchFamily="34" charset="-122"/>
+                          <a:cs typeface="Noto Serif KR Black" pitchFamily="34" charset="-120"/>
                         </a:rPr>
                         <a:t>심폐사</a:t>
                       </a:r>
                       <a:endParaRPr lang="en-US" sz="1800" dirty="0">
-                        <a:latin typeface="Malgun Gothic" charset="0"/>
-                        <a:ea typeface="Malgun Gothic" charset="0"/>
-                        <a:cs typeface="Malgun Gothic" charset="0"/>
+                        <a:latin typeface="Noto Serif KR Black" charset="0"/>
+                        <a:ea typeface="Noto Serif KR Black" charset="0"/>
+                        <a:cs typeface="Noto Serif KR Black" charset="0"/>
                       </a:endParaRPr>
                     </a:p>
                   </a:txBody>
@@ -9600,16 +9600,16 @@
                           <a:solidFill>
                             <a:srgbClr val="222222"/>
                           </a:solidFill>
-                          <a:latin typeface="Malgun Gothic" pitchFamily="34" charset="0"/>
-                          <a:ea typeface="Malgun Gothic" pitchFamily="34" charset="-122"/>
-                          <a:cs typeface="Malgun Gothic" pitchFamily="34" charset="-120"/>
+                          <a:latin typeface="Noto Serif KR Black" pitchFamily="34" charset="0"/>
+                          <a:ea typeface="Noto Serif KR Black" pitchFamily="34" charset="-122"/>
+                          <a:cs typeface="Noto Serif KR Black" pitchFamily="34" charset="-120"/>
                         </a:rPr>
                         <a:t>심장박동과 자발호흡이 비가역적으로 정지한 상태</a:t>
                       </a:r>
                       <a:endParaRPr lang="en-US" sz="1800" dirty="0">
-                        <a:latin typeface="Malgun Gothic" charset="0"/>
-                        <a:ea typeface="Malgun Gothic" charset="0"/>
-                        <a:cs typeface="Malgun Gothic" charset="0"/>
+                        <a:latin typeface="Noto Serif KR Black" charset="0"/>
+                        <a:ea typeface="Noto Serif KR Black" charset="0"/>
+                        <a:cs typeface="Noto Serif KR Black" charset="0"/>
                       </a:endParaRPr>
                     </a:p>
                   </a:txBody>
@@ -9668,16 +9668,16 @@
                           <a:solidFill>
                             <a:srgbClr val="222222"/>
                           </a:solidFill>
-                          <a:latin typeface="Malgun Gothic" pitchFamily="34" charset="0"/>
-                          <a:ea typeface="Malgun Gothic" pitchFamily="34" charset="-122"/>
-                          <a:cs typeface="Malgun Gothic" pitchFamily="34" charset="-120"/>
+                          <a:latin typeface="Noto Serif KR Black" pitchFamily="34" charset="0"/>
+                          <a:ea typeface="Noto Serif KR Black" pitchFamily="34" charset="-122"/>
+                          <a:cs typeface="Noto Serif KR Black" pitchFamily="34" charset="-120"/>
                         </a:rPr>
                         <a:t>일반적으로 죽음을 인식하는 전통적·의학적 기준</a:t>
                       </a:r>
                       <a:endParaRPr lang="en-US" sz="1800" dirty="0">
-                        <a:latin typeface="Malgun Gothic" charset="0"/>
-                        <a:ea typeface="Malgun Gothic" charset="0"/>
-                        <a:cs typeface="Malgun Gothic" charset="0"/>
+                        <a:latin typeface="Noto Serif KR Black" charset="0"/>
+                        <a:ea typeface="Noto Serif KR Black" charset="0"/>
+                        <a:cs typeface="Noto Serif KR Black" charset="0"/>
                       </a:endParaRPr>
                     </a:p>
                   </a:txBody>
@@ -9738,16 +9738,16 @@
                           <a:solidFill>
                             <a:srgbClr val="1F4E4A"/>
                           </a:solidFill>
-                          <a:latin typeface="Malgun Gothic" pitchFamily="34" charset="0"/>
-                          <a:ea typeface="Malgun Gothic" pitchFamily="34" charset="-122"/>
-                          <a:cs typeface="Malgun Gothic" pitchFamily="34" charset="-120"/>
+                          <a:latin typeface="Noto Serif KR Black" pitchFamily="34" charset="0"/>
+                          <a:ea typeface="Noto Serif KR Black" pitchFamily="34" charset="-122"/>
+                          <a:cs typeface="Noto Serif KR Black" pitchFamily="34" charset="-120"/>
                         </a:rPr>
                         <a:t>뇌사</a:t>
                       </a:r>
                       <a:endParaRPr lang="en-US" sz="1800" dirty="0">
-                        <a:latin typeface="Malgun Gothic" charset="0"/>
-                        <a:ea typeface="Malgun Gothic" charset="0"/>
-                        <a:cs typeface="Malgun Gothic" charset="0"/>
+                        <a:latin typeface="Noto Serif KR Black" charset="0"/>
+                        <a:ea typeface="Noto Serif KR Black" charset="0"/>
+                        <a:cs typeface="Noto Serif KR Black" charset="0"/>
                       </a:endParaRPr>
                     </a:p>
                   </a:txBody>
@@ -9806,16 +9806,16 @@
                           <a:solidFill>
                             <a:srgbClr val="222222"/>
                           </a:solidFill>
-                          <a:latin typeface="Malgun Gothic" pitchFamily="34" charset="0"/>
-                          <a:ea typeface="Malgun Gothic" pitchFamily="34" charset="-122"/>
-                          <a:cs typeface="Malgun Gothic" pitchFamily="34" charset="-120"/>
+                          <a:latin typeface="Noto Serif KR Black" pitchFamily="34" charset="0"/>
+                          <a:ea typeface="Noto Serif KR Black" pitchFamily="34" charset="-122"/>
+                          <a:cs typeface="Noto Serif KR Black" pitchFamily="34" charset="-120"/>
                         </a:rPr>
                         <a:t>법이 정한 판정기준·절차에 따라 뇌 전체의 기능이 되살아날 수 없는 상태로 정지되었다고 판정된 경우</a:t>
                       </a:r>
                       <a:endParaRPr lang="en-US" sz="1800" dirty="0">
-                        <a:latin typeface="Malgun Gothic" charset="0"/>
-                        <a:ea typeface="Malgun Gothic" charset="0"/>
-                        <a:cs typeface="Malgun Gothic" charset="0"/>
+                        <a:latin typeface="Noto Serif KR Black" charset="0"/>
+                        <a:ea typeface="Noto Serif KR Black" charset="0"/>
+                        <a:cs typeface="Noto Serif KR Black" charset="0"/>
                       </a:endParaRPr>
                     </a:p>
                   </a:txBody>
@@ -9874,16 +9874,16 @@
                           <a:solidFill>
                             <a:srgbClr val="222222"/>
                           </a:solidFill>
-                          <a:latin typeface="Malgun Gothic" pitchFamily="34" charset="0"/>
-                          <a:ea typeface="Malgun Gothic" pitchFamily="34" charset="-122"/>
-                          <a:cs typeface="Malgun Gothic" pitchFamily="34" charset="-120"/>
+                          <a:latin typeface="Noto Serif KR Black" pitchFamily="34" charset="0"/>
+                          <a:ea typeface="Noto Serif KR Black" pitchFamily="34" charset="-122"/>
+                          <a:cs typeface="Noto Serif KR Black" pitchFamily="34" charset="-120"/>
                         </a:rPr>
                         <a:t>「장기등 이식에 관한 법률」의 엄격한 절차와 장기기증·이식 맥락에서 이해</a:t>
                       </a:r>
                       <a:endParaRPr lang="en-US" sz="1800" dirty="0">
-                        <a:latin typeface="Malgun Gothic" charset="0"/>
-                        <a:ea typeface="Malgun Gothic" charset="0"/>
-                        <a:cs typeface="Malgun Gothic" charset="0"/>
+                        <a:latin typeface="Noto Serif KR Black" charset="0"/>
+                        <a:ea typeface="Noto Serif KR Black" charset="0"/>
+                        <a:cs typeface="Noto Serif KR Black" charset="0"/>
                       </a:endParaRPr>
                     </a:p>
                   </a:txBody>
@@ -17315,16 +17315,16 @@
                           <a:solidFill>
                             <a:srgbClr val="FFFFFF"/>
                           </a:solidFill>
-                          <a:latin typeface="Malgun Gothic" pitchFamily="34" charset="0"/>
-                          <a:ea typeface="Malgun Gothic" pitchFamily="34" charset="-122"/>
-                          <a:cs typeface="Malgun Gothic" pitchFamily="34" charset="-120"/>
+                          <a:latin typeface="Noto Serif KR Black" pitchFamily="34" charset="0"/>
+                          <a:ea typeface="Noto Serif KR Black" pitchFamily="34" charset="-122"/>
+                          <a:cs typeface="Noto Serif KR Black" pitchFamily="34" charset="-120"/>
                         </a:rPr>
                         <a:t>단계</a:t>
                       </a:r>
                       <a:endParaRPr lang="en-US" sz="1700" dirty="0">
-                        <a:latin typeface="Malgun Gothic" charset="0"/>
-                        <a:ea typeface="Malgun Gothic" charset="0"/>
-                        <a:cs typeface="Malgun Gothic" charset="0"/>
+                        <a:latin typeface="Noto Serif KR Black" charset="0"/>
+                        <a:ea typeface="Noto Serif KR Black" charset="0"/>
+                        <a:cs typeface="Noto Serif KR Black" charset="0"/>
                       </a:endParaRPr>
                     </a:p>
                   </a:txBody>
@@ -17383,16 +17383,16 @@
                           <a:solidFill>
                             <a:srgbClr val="FFFFFF"/>
                           </a:solidFill>
-                          <a:latin typeface="Malgun Gothic" pitchFamily="34" charset="0"/>
-                          <a:ea typeface="Malgun Gothic" pitchFamily="34" charset="-122"/>
-                          <a:cs typeface="Malgun Gothic" pitchFamily="34" charset="-120"/>
+                          <a:latin typeface="Noto Serif KR Black" pitchFamily="34" charset="0"/>
+                          <a:ea typeface="Noto Serif KR Black" pitchFamily="34" charset="-122"/>
+                          <a:cs typeface="Noto Serif KR Black" pitchFamily="34" charset="-120"/>
                         </a:rPr>
                         <a:t>대표적 반응</a:t>
                       </a:r>
                       <a:endParaRPr lang="en-US" sz="1700" dirty="0">
-                        <a:latin typeface="Malgun Gothic" charset="0"/>
-                        <a:ea typeface="Malgun Gothic" charset="0"/>
-                        <a:cs typeface="Malgun Gothic" charset="0"/>
+                        <a:latin typeface="Noto Serif KR Black" charset="0"/>
+                        <a:ea typeface="Noto Serif KR Black" charset="0"/>
+                        <a:cs typeface="Noto Serif KR Black" charset="0"/>
                       </a:endParaRPr>
                     </a:p>
                   </a:txBody>
@@ -17451,16 +17451,16 @@
                           <a:solidFill>
                             <a:srgbClr val="FFFFFF"/>
                           </a:solidFill>
-                          <a:latin typeface="Malgun Gothic" pitchFamily="34" charset="0"/>
-                          <a:ea typeface="Malgun Gothic" pitchFamily="34" charset="-122"/>
-                          <a:cs typeface="Malgun Gothic" pitchFamily="34" charset="-120"/>
+                          <a:latin typeface="Noto Serif KR Black" pitchFamily="34" charset="0"/>
+                          <a:ea typeface="Noto Serif KR Black" pitchFamily="34" charset="-122"/>
+                          <a:cs typeface="Noto Serif KR Black" pitchFamily="34" charset="-120"/>
                         </a:rPr>
                         <a:t>WLC의 태도</a:t>
                       </a:r>
                       <a:endParaRPr lang="en-US" sz="1700" dirty="0">
-                        <a:latin typeface="Malgun Gothic" charset="0"/>
-                        <a:ea typeface="Malgun Gothic" charset="0"/>
-                        <a:cs typeface="Malgun Gothic" charset="0"/>
+                        <a:latin typeface="Noto Serif KR Black" charset="0"/>
+                        <a:ea typeface="Noto Serif KR Black" charset="0"/>
+                        <a:cs typeface="Noto Serif KR Black" charset="0"/>
                       </a:endParaRPr>
                     </a:p>
                   </a:txBody>
@@ -17521,16 +17521,16 @@
                           <a:solidFill>
                             <a:srgbClr val="1F4E4A"/>
                           </a:solidFill>
-                          <a:latin typeface="Malgun Gothic" pitchFamily="34" charset="0"/>
-                          <a:ea typeface="Malgun Gothic" pitchFamily="34" charset="-122"/>
-                          <a:cs typeface="Malgun Gothic" pitchFamily="34" charset="-120"/>
+                          <a:latin typeface="Noto Serif KR Black" pitchFamily="34" charset="0"/>
+                          <a:ea typeface="Noto Serif KR Black" pitchFamily="34" charset="-122"/>
+                          <a:cs typeface="Noto Serif KR Black" pitchFamily="34" charset="-120"/>
                         </a:rPr>
                         <a:t>부정</a:t>
                       </a:r>
                       <a:endParaRPr lang="en-US" sz="1700" dirty="0">
-                        <a:latin typeface="Malgun Gothic" charset="0"/>
-                        <a:ea typeface="Malgun Gothic" charset="0"/>
-                        <a:cs typeface="Malgun Gothic" charset="0"/>
+                        <a:latin typeface="Noto Serif KR Black" charset="0"/>
+                        <a:ea typeface="Noto Serif KR Black" charset="0"/>
+                        <a:cs typeface="Noto Serif KR Black" charset="0"/>
                       </a:endParaRPr>
                     </a:p>
                   </a:txBody>
@@ -17589,16 +17589,16 @@
                           <a:solidFill>
                             <a:srgbClr val="222222"/>
                           </a:solidFill>
-                          <a:latin typeface="Malgun Gothic" pitchFamily="34" charset="0"/>
-                          <a:ea typeface="Malgun Gothic" pitchFamily="34" charset="-122"/>
-                          <a:cs typeface="Malgun Gothic" pitchFamily="34" charset="-120"/>
+                          <a:latin typeface="Noto Serif KR Black" pitchFamily="34" charset="0"/>
+                          <a:ea typeface="Noto Serif KR Black" pitchFamily="34" charset="-122"/>
+                          <a:cs typeface="Noto Serif KR Black" pitchFamily="34" charset="-120"/>
                         </a:rPr>
                         <a:t>“사실이 아닐 거야.”</a:t>
                       </a:r>
                       <a:endParaRPr lang="en-US" sz="1700" dirty="0">
-                        <a:latin typeface="Malgun Gothic" charset="0"/>
-                        <a:ea typeface="Malgun Gothic" charset="0"/>
-                        <a:cs typeface="Malgun Gothic" charset="0"/>
+                        <a:latin typeface="Noto Serif KR Black" charset="0"/>
+                        <a:ea typeface="Noto Serif KR Black" charset="0"/>
+                        <a:cs typeface="Noto Serif KR Black" charset="0"/>
                       </a:endParaRPr>
                     </a:p>
                   </a:txBody>
@@ -17657,16 +17657,16 @@
                           <a:solidFill>
                             <a:srgbClr val="222222"/>
                           </a:solidFill>
-                          <a:latin typeface="Malgun Gothic" pitchFamily="34" charset="0"/>
-                          <a:ea typeface="Malgun Gothic" pitchFamily="34" charset="-122"/>
-                          <a:cs typeface="Malgun Gothic" pitchFamily="34" charset="-120"/>
+                          <a:latin typeface="Noto Serif KR Black" pitchFamily="34" charset="0"/>
+                          <a:ea typeface="Noto Serif KR Black" pitchFamily="34" charset="-122"/>
+                          <a:cs typeface="Noto Serif KR Black" pitchFamily="34" charset="-120"/>
                         </a:rPr>
                         <a:t>현실을 서둘러 강요하지 않고 안전하게 들을 시간을 준다</a:t>
                       </a:r>
                       <a:endParaRPr lang="en-US" sz="1700" dirty="0">
-                        <a:latin typeface="Malgun Gothic" charset="0"/>
-                        <a:ea typeface="Malgun Gothic" charset="0"/>
-                        <a:cs typeface="Malgun Gothic" charset="0"/>
+                        <a:latin typeface="Noto Serif KR Black" charset="0"/>
+                        <a:ea typeface="Noto Serif KR Black" charset="0"/>
+                        <a:cs typeface="Noto Serif KR Black" charset="0"/>
                       </a:endParaRPr>
                     </a:p>
                   </a:txBody>
@@ -17727,16 +17727,16 @@
                           <a:solidFill>
                             <a:srgbClr val="1F4E4A"/>
                           </a:solidFill>
-                          <a:latin typeface="Malgun Gothic" pitchFamily="34" charset="0"/>
-                          <a:ea typeface="Malgun Gothic" pitchFamily="34" charset="-122"/>
-                          <a:cs typeface="Malgun Gothic" pitchFamily="34" charset="-120"/>
+                          <a:latin typeface="Noto Serif KR Black" pitchFamily="34" charset="0"/>
+                          <a:ea typeface="Noto Serif KR Black" pitchFamily="34" charset="-122"/>
+                          <a:cs typeface="Noto Serif KR Black" pitchFamily="34" charset="-120"/>
                         </a:rPr>
                         <a:t>분노</a:t>
                       </a:r>
                       <a:endParaRPr lang="en-US" sz="1700" dirty="0">
-                        <a:latin typeface="Malgun Gothic" charset="0"/>
-                        <a:ea typeface="Malgun Gothic" charset="0"/>
-                        <a:cs typeface="Malgun Gothic" charset="0"/>
+                        <a:latin typeface="Noto Serif KR Black" charset="0"/>
+                        <a:ea typeface="Noto Serif KR Black" charset="0"/>
+                        <a:cs typeface="Noto Serif KR Black" charset="0"/>
                       </a:endParaRPr>
                     </a:p>
                   </a:txBody>
@@ -17795,16 +17795,16 @@
                           <a:solidFill>
                             <a:srgbClr val="222222"/>
                           </a:solidFill>
-                          <a:latin typeface="Malgun Gothic" pitchFamily="34" charset="0"/>
-                          <a:ea typeface="Malgun Gothic" pitchFamily="34" charset="-122"/>
-                          <a:cs typeface="Malgun Gothic" pitchFamily="34" charset="-120"/>
+                          <a:latin typeface="Noto Serif KR Black" pitchFamily="34" charset="0"/>
+                          <a:ea typeface="Noto Serif KR Black" pitchFamily="34" charset="-122"/>
+                          <a:cs typeface="Noto Serif KR Black" pitchFamily="34" charset="-120"/>
                         </a:rPr>
                         <a:t>“왜 하필 나인가.”</a:t>
                       </a:r>
                       <a:endParaRPr lang="en-US" sz="1700" dirty="0">
-                        <a:latin typeface="Malgun Gothic" charset="0"/>
-                        <a:ea typeface="Malgun Gothic" charset="0"/>
-                        <a:cs typeface="Malgun Gothic" charset="0"/>
+                        <a:latin typeface="Noto Serif KR Black" charset="0"/>
+                        <a:ea typeface="Noto Serif KR Black" charset="0"/>
+                        <a:cs typeface="Noto Serif KR Black" charset="0"/>
                       </a:endParaRPr>
                     </a:p>
                   </a:txBody>
@@ -17863,16 +17863,16 @@
                           <a:solidFill>
                             <a:srgbClr val="222222"/>
                           </a:solidFill>
-                          <a:latin typeface="Malgun Gothic" pitchFamily="34" charset="0"/>
-                          <a:ea typeface="Malgun Gothic" pitchFamily="34" charset="-122"/>
-                          <a:cs typeface="Malgun Gothic" pitchFamily="34" charset="-120"/>
+                          <a:latin typeface="Noto Serif KR Black" pitchFamily="34" charset="0"/>
+                          <a:ea typeface="Noto Serif KR Black" pitchFamily="34" charset="-122"/>
+                          <a:cs typeface="Noto Serif KR Black" pitchFamily="34" charset="-120"/>
                         </a:rPr>
                         <a:t>분노를 판단하지 않고 그 밑의 두려움과 상실을 탐색한다</a:t>
                       </a:r>
                       <a:endParaRPr lang="en-US" sz="1700" dirty="0">
-                        <a:latin typeface="Malgun Gothic" charset="0"/>
-                        <a:ea typeface="Malgun Gothic" charset="0"/>
-                        <a:cs typeface="Malgun Gothic" charset="0"/>
+                        <a:latin typeface="Noto Serif KR Black" charset="0"/>
+                        <a:ea typeface="Noto Serif KR Black" charset="0"/>
+                        <a:cs typeface="Noto Serif KR Black" charset="0"/>
                       </a:endParaRPr>
                     </a:p>
                   </a:txBody>
@@ -17933,16 +17933,16 @@
                           <a:solidFill>
                             <a:srgbClr val="1F4E4A"/>
                           </a:solidFill>
-                          <a:latin typeface="Malgun Gothic" pitchFamily="34" charset="0"/>
-                          <a:ea typeface="Malgun Gothic" pitchFamily="34" charset="-122"/>
-                          <a:cs typeface="Malgun Gothic" pitchFamily="34" charset="-120"/>
+                          <a:latin typeface="Noto Serif KR Black" pitchFamily="34" charset="0"/>
+                          <a:ea typeface="Noto Serif KR Black" pitchFamily="34" charset="-122"/>
+                          <a:cs typeface="Noto Serif KR Black" pitchFamily="34" charset="-120"/>
                         </a:rPr>
                         <a:t>타협</a:t>
                       </a:r>
                       <a:endParaRPr lang="en-US" sz="1700" dirty="0">
-                        <a:latin typeface="Malgun Gothic" charset="0"/>
-                        <a:ea typeface="Malgun Gothic" charset="0"/>
-                        <a:cs typeface="Malgun Gothic" charset="0"/>
+                        <a:latin typeface="Noto Serif KR Black" charset="0"/>
+                        <a:ea typeface="Noto Serif KR Black" charset="0"/>
+                        <a:cs typeface="Noto Serif KR Black" charset="0"/>
                       </a:endParaRPr>
                     </a:p>
                   </a:txBody>
@@ -18001,16 +18001,16 @@
                           <a:solidFill>
                             <a:srgbClr val="222222"/>
                           </a:solidFill>
-                          <a:latin typeface="Malgun Gothic" pitchFamily="34" charset="0"/>
-                          <a:ea typeface="Malgun Gothic" pitchFamily="34" charset="-122"/>
-                          <a:cs typeface="Malgun Gothic" pitchFamily="34" charset="-120"/>
+                          <a:latin typeface="Noto Serif KR Black" pitchFamily="34" charset="0"/>
+                          <a:ea typeface="Noto Serif KR Black" pitchFamily="34" charset="-122"/>
+                          <a:cs typeface="Noto Serif KR Black" pitchFamily="34" charset="-120"/>
                         </a:rPr>
                         <a:t>“조금만 더 시간을 준다면….”</a:t>
                       </a:r>
                       <a:endParaRPr lang="en-US" sz="1700" dirty="0">
-                        <a:latin typeface="Malgun Gothic" charset="0"/>
-                        <a:ea typeface="Malgun Gothic" charset="0"/>
-                        <a:cs typeface="Malgun Gothic" charset="0"/>
+                        <a:latin typeface="Noto Serif KR Black" charset="0"/>
+                        <a:ea typeface="Noto Serif KR Black" charset="0"/>
+                        <a:cs typeface="Noto Serif KR Black" charset="0"/>
                       </a:endParaRPr>
                     </a:p>
                   </a:txBody>
@@ -18069,16 +18069,16 @@
                           <a:solidFill>
                             <a:srgbClr val="222222"/>
                           </a:solidFill>
-                          <a:latin typeface="Malgun Gothic" pitchFamily="34" charset="0"/>
-                          <a:ea typeface="Malgun Gothic" pitchFamily="34" charset="-122"/>
-                          <a:cs typeface="Malgun Gothic" pitchFamily="34" charset="-120"/>
+                          <a:latin typeface="Noto Serif KR Black" pitchFamily="34" charset="0"/>
+                          <a:ea typeface="Noto Serif KR Black" pitchFamily="34" charset="-122"/>
+                          <a:cs typeface="Noto Serif KR Black" pitchFamily="34" charset="-120"/>
                         </a:rPr>
                         <a:t>통제하고 싶은 마음을 이해하고 지금 할 수 있는 선택으로 잇는다</a:t>
                       </a:r>
                       <a:endParaRPr lang="en-US" sz="1700" dirty="0">
-                        <a:latin typeface="Malgun Gothic" charset="0"/>
-                        <a:ea typeface="Malgun Gothic" charset="0"/>
-                        <a:cs typeface="Malgun Gothic" charset="0"/>
+                        <a:latin typeface="Noto Serif KR Black" charset="0"/>
+                        <a:ea typeface="Noto Serif KR Black" charset="0"/>
+                        <a:cs typeface="Noto Serif KR Black" charset="0"/>
                       </a:endParaRPr>
                     </a:p>
                   </a:txBody>
@@ -18139,16 +18139,16 @@
                           <a:solidFill>
                             <a:srgbClr val="1F4E4A"/>
                           </a:solidFill>
-                          <a:latin typeface="Malgun Gothic" pitchFamily="34" charset="0"/>
-                          <a:ea typeface="Malgun Gothic" pitchFamily="34" charset="-122"/>
-                          <a:cs typeface="Malgun Gothic" pitchFamily="34" charset="-120"/>
+                          <a:latin typeface="Noto Serif KR Black" pitchFamily="34" charset="0"/>
+                          <a:ea typeface="Noto Serif KR Black" pitchFamily="34" charset="-122"/>
+                          <a:cs typeface="Noto Serif KR Black" pitchFamily="34" charset="-120"/>
                         </a:rPr>
                         <a:t>우울</a:t>
                       </a:r>
                       <a:endParaRPr lang="en-US" sz="1700" dirty="0">
-                        <a:latin typeface="Malgun Gothic" charset="0"/>
-                        <a:ea typeface="Malgun Gothic" charset="0"/>
-                        <a:cs typeface="Malgun Gothic" charset="0"/>
+                        <a:latin typeface="Noto Serif KR Black" charset="0"/>
+                        <a:ea typeface="Noto Serif KR Black" charset="0"/>
+                        <a:cs typeface="Noto Serif KR Black" charset="0"/>
                       </a:endParaRPr>
                     </a:p>
                   </a:txBody>
@@ -18207,16 +18207,16 @@
                           <a:solidFill>
                             <a:srgbClr val="222222"/>
                           </a:solidFill>
-                          <a:latin typeface="Malgun Gothic" pitchFamily="34" charset="0"/>
-                          <a:ea typeface="Malgun Gothic" pitchFamily="34" charset="-122"/>
-                          <a:cs typeface="Malgun Gothic" pitchFamily="34" charset="-120"/>
+                          <a:latin typeface="Noto Serif KR Black" pitchFamily="34" charset="0"/>
+                          <a:ea typeface="Noto Serif KR Black" pitchFamily="34" charset="-122"/>
+                          <a:cs typeface="Noto Serif KR Black" pitchFamily="34" charset="-120"/>
                         </a:rPr>
                         <a:t>깊은 슬픔, 무기력, 상실감</a:t>
                       </a:r>
                       <a:endParaRPr lang="en-US" sz="1700" dirty="0">
-                        <a:latin typeface="Malgun Gothic" charset="0"/>
-                        <a:ea typeface="Malgun Gothic" charset="0"/>
-                        <a:cs typeface="Malgun Gothic" charset="0"/>
+                        <a:latin typeface="Noto Serif KR Black" charset="0"/>
+                        <a:ea typeface="Noto Serif KR Black" charset="0"/>
+                        <a:cs typeface="Noto Serif KR Black" charset="0"/>
                       </a:endParaRPr>
                     </a:p>
                   </a:txBody>
@@ -18275,16 +18275,16 @@
                           <a:solidFill>
                             <a:srgbClr val="222222"/>
                           </a:solidFill>
-                          <a:latin typeface="Malgun Gothic" pitchFamily="34" charset="0"/>
-                          <a:ea typeface="Malgun Gothic" pitchFamily="34" charset="-122"/>
-                          <a:cs typeface="Malgun Gothic" pitchFamily="34" charset="-120"/>
+                          <a:latin typeface="Noto Serif KR Black" pitchFamily="34" charset="0"/>
+                          <a:ea typeface="Noto Serif KR Black" pitchFamily="34" charset="-122"/>
+                          <a:cs typeface="Noto Serif KR Black" pitchFamily="34" charset="-120"/>
                         </a:rPr>
                         <a:t>섣부른 격려보다 침묵·경청·안전한 지지를 제공한다</a:t>
                       </a:r>
                       <a:endParaRPr lang="en-US" sz="1700" dirty="0">
-                        <a:latin typeface="Malgun Gothic" charset="0"/>
-                        <a:ea typeface="Malgun Gothic" charset="0"/>
-                        <a:cs typeface="Malgun Gothic" charset="0"/>
+                        <a:latin typeface="Noto Serif KR Black" charset="0"/>
+                        <a:ea typeface="Noto Serif KR Black" charset="0"/>
+                        <a:cs typeface="Noto Serif KR Black" charset="0"/>
                       </a:endParaRPr>
                     </a:p>
                   </a:txBody>
@@ -18345,16 +18345,16 @@
                           <a:solidFill>
                             <a:srgbClr val="1F4E4A"/>
                           </a:solidFill>
-                          <a:latin typeface="Malgun Gothic" pitchFamily="34" charset="0"/>
-                          <a:ea typeface="Malgun Gothic" pitchFamily="34" charset="-122"/>
-                          <a:cs typeface="Malgun Gothic" pitchFamily="34" charset="-120"/>
+                          <a:latin typeface="Noto Serif KR Black" pitchFamily="34" charset="0"/>
+                          <a:ea typeface="Noto Serif KR Black" pitchFamily="34" charset="-122"/>
+                          <a:cs typeface="Noto Serif KR Black" pitchFamily="34" charset="-120"/>
                         </a:rPr>
                         <a:t>수용</a:t>
                       </a:r>
                       <a:endParaRPr lang="en-US" sz="1700" dirty="0">
-                        <a:latin typeface="Malgun Gothic" charset="0"/>
-                        <a:ea typeface="Malgun Gothic" charset="0"/>
-                        <a:cs typeface="Malgun Gothic" charset="0"/>
+                        <a:latin typeface="Noto Serif KR Black" charset="0"/>
+                        <a:ea typeface="Noto Serif KR Black" charset="0"/>
+                        <a:cs typeface="Noto Serif KR Black" charset="0"/>
                       </a:endParaRPr>
                     </a:p>
                   </a:txBody>
@@ -18413,16 +18413,16 @@
                           <a:solidFill>
                             <a:srgbClr val="222222"/>
                           </a:solidFill>
-                          <a:latin typeface="Malgun Gothic" pitchFamily="34" charset="0"/>
-                          <a:ea typeface="Malgun Gothic" pitchFamily="34" charset="-122"/>
-                          <a:cs typeface="Malgun Gothic" pitchFamily="34" charset="-120"/>
+                          <a:latin typeface="Noto Serif KR Black" pitchFamily="34" charset="0"/>
+                          <a:ea typeface="Noto Serif KR Black" pitchFamily="34" charset="-122"/>
+                          <a:cs typeface="Noto Serif KR Black" pitchFamily="34" charset="-120"/>
                         </a:rPr>
                         <a:t>현실을 받아들이며 정리하기 시작</a:t>
                       </a:r>
                       <a:endParaRPr lang="en-US" sz="1700" dirty="0">
-                        <a:latin typeface="Malgun Gothic" charset="0"/>
-                        <a:ea typeface="Malgun Gothic" charset="0"/>
-                        <a:cs typeface="Malgun Gothic" charset="0"/>
+                        <a:latin typeface="Noto Serif KR Black" charset="0"/>
+                        <a:ea typeface="Noto Serif KR Black" charset="0"/>
+                        <a:cs typeface="Noto Serif KR Black" charset="0"/>
                       </a:endParaRPr>
                     </a:p>
                   </a:txBody>
@@ -18481,16 +18481,16 @@
                           <a:solidFill>
                             <a:srgbClr val="222222"/>
                           </a:solidFill>
-                          <a:latin typeface="Malgun Gothic" pitchFamily="34" charset="0"/>
-                          <a:ea typeface="Malgun Gothic" pitchFamily="34" charset="-122"/>
-                          <a:cs typeface="Malgun Gothic" pitchFamily="34" charset="-120"/>
+                          <a:latin typeface="Noto Serif KR Black" pitchFamily="34" charset="0"/>
+                          <a:ea typeface="Noto Serif KR Black" pitchFamily="34" charset="-122"/>
+                          <a:cs typeface="Noto Serif KR Black" pitchFamily="34" charset="-120"/>
                         </a:rPr>
                         <a:t>관계·가치·마지막 바람을 구체화하도록 돕는다</a:t>
                       </a:r>
                       <a:endParaRPr lang="en-US" sz="1700" dirty="0">
-                        <a:latin typeface="Malgun Gothic" charset="0"/>
-                        <a:ea typeface="Malgun Gothic" charset="0"/>
-                        <a:cs typeface="Malgun Gothic" charset="0"/>
+                        <a:latin typeface="Noto Serif KR Black" charset="0"/>
+                        <a:ea typeface="Noto Serif KR Black" charset="0"/>
+                        <a:cs typeface="Noto Serif KR Black" charset="0"/>
                       </a:endParaRPr>
                     </a:p>
                   </a:txBody>
@@ -19240,16 +19240,16 @@
                           <a:solidFill>
                             <a:srgbClr val="FFFFFF"/>
                           </a:solidFill>
-                          <a:latin typeface="Malgun Gothic" pitchFamily="34" charset="0"/>
-                          <a:ea typeface="Malgun Gothic" pitchFamily="34" charset="-122"/>
-                          <a:cs typeface="Malgun Gothic" pitchFamily="34" charset="-120"/>
+                          <a:latin typeface="Noto Serif KR Black" pitchFamily="34" charset="0"/>
+                          <a:ea typeface="Noto Serif KR Black" pitchFamily="34" charset="-122"/>
+                          <a:cs typeface="Noto Serif KR Black" pitchFamily="34" charset="-120"/>
                         </a:rPr>
                         <a:t>불안의 유형</a:t>
                       </a:r>
                       <a:endParaRPr lang="en-US" sz="1600" dirty="0">
-                        <a:latin typeface="Malgun Gothic" charset="0"/>
-                        <a:ea typeface="Malgun Gothic" charset="0"/>
-                        <a:cs typeface="Malgun Gothic" charset="0"/>
+                        <a:latin typeface="Noto Serif KR Black" charset="0"/>
+                        <a:ea typeface="Noto Serif KR Black" charset="0"/>
+                        <a:cs typeface="Noto Serif KR Black" charset="0"/>
                       </a:endParaRPr>
                     </a:p>
                   </a:txBody>
@@ -19308,16 +19308,16 @@
                           <a:solidFill>
                             <a:srgbClr val="FFFFFF"/>
                           </a:solidFill>
-                          <a:latin typeface="Malgun Gothic" pitchFamily="34" charset="0"/>
-                          <a:ea typeface="Malgun Gothic" pitchFamily="34" charset="-122"/>
-                          <a:cs typeface="Malgun Gothic" pitchFamily="34" charset="-120"/>
+                          <a:latin typeface="Noto Serif KR Black" pitchFamily="34" charset="0"/>
+                          <a:ea typeface="Noto Serif KR Black" pitchFamily="34" charset="-122"/>
+                          <a:cs typeface="Noto Serif KR Black" pitchFamily="34" charset="-120"/>
                         </a:rPr>
                         <a:t>실제로 두려워하는 것</a:t>
                       </a:r>
                       <a:endParaRPr lang="en-US" sz="1600" dirty="0">
-                        <a:latin typeface="Malgun Gothic" charset="0"/>
-                        <a:ea typeface="Malgun Gothic" charset="0"/>
-                        <a:cs typeface="Malgun Gothic" charset="0"/>
+                        <a:latin typeface="Noto Serif KR Black" charset="0"/>
+                        <a:ea typeface="Noto Serif KR Black" charset="0"/>
+                        <a:cs typeface="Noto Serif KR Black" charset="0"/>
                       </a:endParaRPr>
                     </a:p>
                   </a:txBody>
@@ -19376,16 +19376,16 @@
                           <a:solidFill>
                             <a:srgbClr val="FFFFFF"/>
                           </a:solidFill>
-                          <a:latin typeface="Malgun Gothic" pitchFamily="34" charset="0"/>
-                          <a:ea typeface="Malgun Gothic" pitchFamily="34" charset="-122"/>
-                          <a:cs typeface="Malgun Gothic" pitchFamily="34" charset="-120"/>
+                          <a:latin typeface="Noto Serif KR Black" pitchFamily="34" charset="0"/>
+                          <a:ea typeface="Noto Serif KR Black" pitchFamily="34" charset="-122"/>
+                          <a:cs typeface="Noto Serif KR Black" pitchFamily="34" charset="-120"/>
                         </a:rPr>
                         <a:t>WLC 탐색 질문</a:t>
                       </a:r>
                       <a:endParaRPr lang="en-US" sz="1600" dirty="0">
-                        <a:latin typeface="Malgun Gothic" charset="0"/>
-                        <a:ea typeface="Malgun Gothic" charset="0"/>
-                        <a:cs typeface="Malgun Gothic" charset="0"/>
+                        <a:latin typeface="Noto Serif KR Black" charset="0"/>
+                        <a:ea typeface="Noto Serif KR Black" charset="0"/>
+                        <a:cs typeface="Noto Serif KR Black" charset="0"/>
                       </a:endParaRPr>
                     </a:p>
                   </a:txBody>
@@ -19446,16 +19446,16 @@
                           <a:solidFill>
                             <a:srgbClr val="1F4E4A"/>
                           </a:solidFill>
-                          <a:latin typeface="Malgun Gothic" pitchFamily="34" charset="0"/>
-                          <a:ea typeface="Malgun Gothic" pitchFamily="34" charset="-122"/>
-                          <a:cs typeface="Malgun Gothic" pitchFamily="34" charset="-120"/>
+                          <a:latin typeface="Noto Serif KR Black" pitchFamily="34" charset="0"/>
+                          <a:ea typeface="Noto Serif KR Black" pitchFamily="34" charset="-122"/>
+                          <a:cs typeface="Noto Serif KR Black" pitchFamily="34" charset="-120"/>
                         </a:rPr>
                         <a:t>미지의 불안</a:t>
                       </a:r>
                       <a:endParaRPr lang="en-US" sz="1600" dirty="0">
-                        <a:latin typeface="Malgun Gothic" charset="0"/>
-                        <a:ea typeface="Malgun Gothic" charset="0"/>
-                        <a:cs typeface="Malgun Gothic" charset="0"/>
+                        <a:latin typeface="Noto Serif KR Black" charset="0"/>
+                        <a:ea typeface="Noto Serif KR Black" charset="0"/>
+                        <a:cs typeface="Noto Serif KR Black" charset="0"/>
                       </a:endParaRPr>
                     </a:p>
                   </a:txBody>
@@ -19514,16 +19514,16 @@
                           <a:solidFill>
                             <a:srgbClr val="222222"/>
                           </a:solidFill>
-                          <a:latin typeface="Malgun Gothic" pitchFamily="34" charset="0"/>
-                          <a:ea typeface="Malgun Gothic" pitchFamily="34" charset="-122"/>
-                          <a:cs typeface="Malgun Gothic" pitchFamily="34" charset="-120"/>
+                          <a:latin typeface="Noto Serif KR Black" pitchFamily="34" charset="0"/>
+                          <a:ea typeface="Noto Serif KR Black" pitchFamily="34" charset="-122"/>
+                          <a:cs typeface="Noto Serif KR Black" pitchFamily="34" charset="-120"/>
                         </a:rPr>
                         <a:t>죽음 이후를 알 수 없음</a:t>
                       </a:r>
                       <a:endParaRPr lang="en-US" sz="1600" dirty="0">
-                        <a:latin typeface="Malgun Gothic" charset="0"/>
-                        <a:ea typeface="Malgun Gothic" charset="0"/>
-                        <a:cs typeface="Malgun Gothic" charset="0"/>
+                        <a:latin typeface="Noto Serif KR Black" charset="0"/>
+                        <a:ea typeface="Noto Serif KR Black" charset="0"/>
+                        <a:cs typeface="Noto Serif KR Black" charset="0"/>
                       </a:endParaRPr>
                     </a:p>
                   </a:txBody>
@@ -19582,16 +19582,16 @@
                           <a:solidFill>
                             <a:srgbClr val="222222"/>
                           </a:solidFill>
-                          <a:latin typeface="Malgun Gothic" pitchFamily="34" charset="0"/>
-                          <a:ea typeface="Malgun Gothic" pitchFamily="34" charset="-122"/>
-                          <a:cs typeface="Malgun Gothic" pitchFamily="34" charset="-120"/>
+                          <a:latin typeface="Noto Serif KR Black" pitchFamily="34" charset="0"/>
+                          <a:ea typeface="Noto Serif KR Black" pitchFamily="34" charset="-122"/>
+                          <a:cs typeface="Noto Serif KR Black" pitchFamily="34" charset="-120"/>
                         </a:rPr>
                         <a:t>“가장 알 수 없어서 두려운 것은 무엇인가요?”</a:t>
                       </a:r>
                       <a:endParaRPr lang="en-US" sz="1600" dirty="0">
-                        <a:latin typeface="Malgun Gothic" charset="0"/>
-                        <a:ea typeface="Malgun Gothic" charset="0"/>
-                        <a:cs typeface="Malgun Gothic" charset="0"/>
+                        <a:latin typeface="Noto Serif KR Black" charset="0"/>
+                        <a:ea typeface="Noto Serif KR Black" charset="0"/>
+                        <a:cs typeface="Noto Serif KR Black" charset="0"/>
                       </a:endParaRPr>
                     </a:p>
                   </a:txBody>
@@ -19652,16 +19652,16 @@
                           <a:solidFill>
                             <a:srgbClr val="1F4E4A"/>
                           </a:solidFill>
-                          <a:latin typeface="Malgun Gothic" pitchFamily="34" charset="0"/>
-                          <a:ea typeface="Malgun Gothic" pitchFamily="34" charset="-122"/>
-                          <a:cs typeface="Malgun Gothic" pitchFamily="34" charset="-120"/>
+                          <a:latin typeface="Noto Serif KR Black" pitchFamily="34" charset="0"/>
+                          <a:ea typeface="Noto Serif KR Black" pitchFamily="34" charset="-122"/>
+                          <a:cs typeface="Noto Serif KR Black" pitchFamily="34" charset="-120"/>
                         </a:rPr>
                         <a:t>고통의 불안</a:t>
                       </a:r>
                       <a:endParaRPr lang="en-US" sz="1600" dirty="0">
-                        <a:latin typeface="Malgun Gothic" charset="0"/>
-                        <a:ea typeface="Malgun Gothic" charset="0"/>
-                        <a:cs typeface="Malgun Gothic" charset="0"/>
+                        <a:latin typeface="Noto Serif KR Black" charset="0"/>
+                        <a:ea typeface="Noto Serif KR Black" charset="0"/>
+                        <a:cs typeface="Noto Serif KR Black" charset="0"/>
                       </a:endParaRPr>
                     </a:p>
                   </a:txBody>
@@ -19720,16 +19720,16 @@
                           <a:solidFill>
                             <a:srgbClr val="222222"/>
                           </a:solidFill>
-                          <a:latin typeface="Malgun Gothic" pitchFamily="34" charset="0"/>
-                          <a:ea typeface="Malgun Gothic" pitchFamily="34" charset="-122"/>
-                          <a:cs typeface="Malgun Gothic" pitchFamily="34" charset="-120"/>
+                          <a:latin typeface="Noto Serif KR Black" pitchFamily="34" charset="0"/>
+                          <a:ea typeface="Noto Serif KR Black" pitchFamily="34" charset="-122"/>
+                          <a:cs typeface="Noto Serif KR Black" pitchFamily="34" charset="-120"/>
                         </a:rPr>
                         <a:t>통증·호흡곤란·기능상실</a:t>
                       </a:r>
                       <a:endParaRPr lang="en-US" sz="1600" dirty="0">
-                        <a:latin typeface="Malgun Gothic" charset="0"/>
-                        <a:ea typeface="Malgun Gothic" charset="0"/>
-                        <a:cs typeface="Malgun Gothic" charset="0"/>
+                        <a:latin typeface="Noto Serif KR Black" charset="0"/>
+                        <a:ea typeface="Noto Serif KR Black" charset="0"/>
+                        <a:cs typeface="Noto Serif KR Black" charset="0"/>
                       </a:endParaRPr>
                     </a:p>
                   </a:txBody>
@@ -19788,16 +19788,16 @@
                           <a:solidFill>
                             <a:srgbClr val="222222"/>
                           </a:solidFill>
-                          <a:latin typeface="Malgun Gothic" pitchFamily="34" charset="0"/>
-                          <a:ea typeface="Malgun Gothic" pitchFamily="34" charset="-122"/>
-                          <a:cs typeface="Malgun Gothic" pitchFamily="34" charset="-120"/>
+                          <a:latin typeface="Noto Serif KR Black" pitchFamily="34" charset="0"/>
+                          <a:ea typeface="Noto Serif KR Black" pitchFamily="34" charset="-122"/>
+                          <a:cs typeface="Noto Serif KR Black" pitchFamily="34" charset="-120"/>
                         </a:rPr>
                         <a:t>“죽음보다 죽어가는 과정이 더 걱정되시나요?”</a:t>
                       </a:r>
                       <a:endParaRPr lang="en-US" sz="1600" dirty="0">
-                        <a:latin typeface="Malgun Gothic" charset="0"/>
-                        <a:ea typeface="Malgun Gothic" charset="0"/>
-                        <a:cs typeface="Malgun Gothic" charset="0"/>
+                        <a:latin typeface="Noto Serif KR Black" charset="0"/>
+                        <a:ea typeface="Noto Serif KR Black" charset="0"/>
+                        <a:cs typeface="Noto Serif KR Black" charset="0"/>
                       </a:endParaRPr>
                     </a:p>
                   </a:txBody>
@@ -19858,16 +19858,16 @@
                           <a:solidFill>
                             <a:srgbClr val="1F4E4A"/>
                           </a:solidFill>
-                          <a:latin typeface="Malgun Gothic" pitchFamily="34" charset="0"/>
-                          <a:ea typeface="Malgun Gothic" pitchFamily="34" charset="-122"/>
-                          <a:cs typeface="Malgun Gothic" pitchFamily="34" charset="-120"/>
+                          <a:latin typeface="Noto Serif KR Black" pitchFamily="34" charset="0"/>
+                          <a:ea typeface="Noto Serif KR Black" pitchFamily="34" charset="-122"/>
+                          <a:cs typeface="Noto Serif KR Black" pitchFamily="34" charset="-120"/>
                         </a:rPr>
                         <a:t>관계상실의 불안</a:t>
                       </a:r>
                       <a:endParaRPr lang="en-US" sz="1600" dirty="0">
-                        <a:latin typeface="Malgun Gothic" charset="0"/>
-                        <a:ea typeface="Malgun Gothic" charset="0"/>
-                        <a:cs typeface="Malgun Gothic" charset="0"/>
+                        <a:latin typeface="Noto Serif KR Black" charset="0"/>
+                        <a:ea typeface="Noto Serif KR Black" charset="0"/>
+                        <a:cs typeface="Noto Serif KR Black" charset="0"/>
                       </a:endParaRPr>
                     </a:p>
                   </a:txBody>
@@ -19926,16 +19926,16 @@
                           <a:solidFill>
                             <a:srgbClr val="222222"/>
                           </a:solidFill>
-                          <a:latin typeface="Malgun Gothic" pitchFamily="34" charset="0"/>
-                          <a:ea typeface="Malgun Gothic" pitchFamily="34" charset="-122"/>
-                          <a:cs typeface="Malgun Gothic" pitchFamily="34" charset="-120"/>
+                          <a:latin typeface="Noto Serif KR Black" pitchFamily="34" charset="0"/>
+                          <a:ea typeface="Noto Serif KR Black" pitchFamily="34" charset="-122"/>
+                          <a:cs typeface="Noto Serif KR Black" pitchFamily="34" charset="-120"/>
                         </a:rPr>
                         <a:t>사랑하는 사람과의 이별</a:t>
                       </a:r>
                       <a:endParaRPr lang="en-US" sz="1600" dirty="0">
-                        <a:latin typeface="Malgun Gothic" charset="0"/>
-                        <a:ea typeface="Malgun Gothic" charset="0"/>
-                        <a:cs typeface="Malgun Gothic" charset="0"/>
+                        <a:latin typeface="Noto Serif KR Black" charset="0"/>
+                        <a:ea typeface="Noto Serif KR Black" charset="0"/>
+                        <a:cs typeface="Noto Serif KR Black" charset="0"/>
                       </a:endParaRPr>
                     </a:p>
                   </a:txBody>
@@ -19994,16 +19994,16 @@
                           <a:solidFill>
                             <a:srgbClr val="222222"/>
                           </a:solidFill>
-                          <a:latin typeface="Malgun Gothic" pitchFamily="34" charset="0"/>
-                          <a:ea typeface="Malgun Gothic" pitchFamily="34" charset="-122"/>
-                          <a:cs typeface="Malgun Gothic" pitchFamily="34" charset="-120"/>
+                          <a:latin typeface="Noto Serif KR Black" pitchFamily="34" charset="0"/>
+                          <a:ea typeface="Noto Serif KR Black" pitchFamily="34" charset="-122"/>
+                          <a:cs typeface="Noto Serif KR Black" pitchFamily="34" charset="-120"/>
                         </a:rPr>
                         <a:t>“누구와 헤어지는 일이 가장 마음에 남습니까?”</a:t>
                       </a:r>
                       <a:endParaRPr lang="en-US" sz="1600" dirty="0">
-                        <a:latin typeface="Malgun Gothic" charset="0"/>
-                        <a:ea typeface="Malgun Gothic" charset="0"/>
-                        <a:cs typeface="Malgun Gothic" charset="0"/>
+                        <a:latin typeface="Noto Serif KR Black" charset="0"/>
+                        <a:ea typeface="Noto Serif KR Black" charset="0"/>
+                        <a:cs typeface="Noto Serif KR Black" charset="0"/>
                       </a:endParaRPr>
                     </a:p>
                   </a:txBody>
@@ -20064,16 +20064,16 @@
                           <a:solidFill>
                             <a:srgbClr val="1F4E4A"/>
                           </a:solidFill>
-                          <a:latin typeface="Malgun Gothic" pitchFamily="34" charset="0"/>
-                          <a:ea typeface="Malgun Gothic" pitchFamily="34" charset="-122"/>
-                          <a:cs typeface="Malgun Gothic" pitchFamily="34" charset="-120"/>
+                          <a:latin typeface="Noto Serif KR Black" pitchFamily="34" charset="0"/>
+                          <a:ea typeface="Noto Serif KR Black" pitchFamily="34" charset="-122"/>
+                          <a:cs typeface="Noto Serif KR Black" pitchFamily="34" charset="-120"/>
                         </a:rPr>
                         <a:t>고독의 불안</a:t>
                       </a:r>
                       <a:endParaRPr lang="en-US" sz="1600" dirty="0">
-                        <a:latin typeface="Malgun Gothic" charset="0"/>
-                        <a:ea typeface="Malgun Gothic" charset="0"/>
-                        <a:cs typeface="Malgun Gothic" charset="0"/>
+                        <a:latin typeface="Noto Serif KR Black" charset="0"/>
+                        <a:ea typeface="Noto Serif KR Black" charset="0"/>
+                        <a:cs typeface="Noto Serif KR Black" charset="0"/>
                       </a:endParaRPr>
                     </a:p>
                   </a:txBody>
@@ -20132,16 +20132,16 @@
                           <a:solidFill>
                             <a:srgbClr val="222222"/>
                           </a:solidFill>
-                          <a:latin typeface="Malgun Gothic" pitchFamily="34" charset="0"/>
-                          <a:ea typeface="Malgun Gothic" pitchFamily="34" charset="-122"/>
-                          <a:cs typeface="Malgun Gothic" pitchFamily="34" charset="-120"/>
+                          <a:latin typeface="Noto Serif KR Black" pitchFamily="34" charset="0"/>
+                          <a:ea typeface="Noto Serif KR Black" pitchFamily="34" charset="-122"/>
+                          <a:cs typeface="Noto Serif KR Black" pitchFamily="34" charset="-120"/>
                         </a:rPr>
                         <a:t>혼자 죽거나 발견되지 않음</a:t>
                       </a:r>
                       <a:endParaRPr lang="en-US" sz="1600" dirty="0">
-                        <a:latin typeface="Malgun Gothic" charset="0"/>
-                        <a:ea typeface="Malgun Gothic" charset="0"/>
-                        <a:cs typeface="Malgun Gothic" charset="0"/>
+                        <a:latin typeface="Noto Serif KR Black" charset="0"/>
+                        <a:ea typeface="Noto Serif KR Black" charset="0"/>
+                        <a:cs typeface="Noto Serif KR Black" charset="0"/>
                       </a:endParaRPr>
                     </a:p>
                   </a:txBody>
@@ -20200,16 +20200,16 @@
                           <a:solidFill>
                             <a:srgbClr val="222222"/>
                           </a:solidFill>
-                          <a:latin typeface="Malgun Gothic" pitchFamily="34" charset="0"/>
-                          <a:ea typeface="Malgun Gothic" pitchFamily="34" charset="-122"/>
-                          <a:cs typeface="Malgun Gothic" pitchFamily="34" charset="-120"/>
+                          <a:latin typeface="Noto Serif KR Black" pitchFamily="34" charset="0"/>
+                          <a:ea typeface="Noto Serif KR Black" pitchFamily="34" charset="-122"/>
+                          <a:cs typeface="Noto Serif KR Black" pitchFamily="34" charset="-120"/>
                         </a:rPr>
                         <a:t>“마지막에 누구와 연결되어 있고 싶으신가요?”</a:t>
                       </a:r>
                       <a:endParaRPr lang="en-US" sz="1600" dirty="0">
-                        <a:latin typeface="Malgun Gothic" charset="0"/>
-                        <a:ea typeface="Malgun Gothic" charset="0"/>
-                        <a:cs typeface="Malgun Gothic" charset="0"/>
+                        <a:latin typeface="Noto Serif KR Black" charset="0"/>
+                        <a:ea typeface="Noto Serif KR Black" charset="0"/>
+                        <a:cs typeface="Noto Serif KR Black" charset="0"/>
                       </a:endParaRPr>
                     </a:p>
                   </a:txBody>
@@ -20270,16 +20270,16 @@
                           <a:solidFill>
                             <a:srgbClr val="1F4E4A"/>
                           </a:solidFill>
-                          <a:latin typeface="Malgun Gothic" pitchFamily="34" charset="0"/>
-                          <a:ea typeface="Malgun Gothic" pitchFamily="34" charset="-122"/>
-                          <a:cs typeface="Malgun Gothic" pitchFamily="34" charset="-120"/>
+                          <a:latin typeface="Noto Serif KR Black" pitchFamily="34" charset="0"/>
+                          <a:ea typeface="Noto Serif KR Black" pitchFamily="34" charset="-122"/>
+                          <a:cs typeface="Noto Serif KR Black" pitchFamily="34" charset="-120"/>
                         </a:rPr>
                         <a:t>미완성의 불안</a:t>
                       </a:r>
                       <a:endParaRPr lang="en-US" sz="1600" dirty="0">
-                        <a:latin typeface="Malgun Gothic" charset="0"/>
-                        <a:ea typeface="Malgun Gothic" charset="0"/>
-                        <a:cs typeface="Malgun Gothic" charset="0"/>
+                        <a:latin typeface="Noto Serif KR Black" charset="0"/>
+                        <a:ea typeface="Noto Serif KR Black" charset="0"/>
+                        <a:cs typeface="Noto Serif KR Black" charset="0"/>
                       </a:endParaRPr>
                     </a:p>
                   </a:txBody>
@@ -20338,16 +20338,16 @@
                           <a:solidFill>
                             <a:srgbClr val="222222"/>
                           </a:solidFill>
-                          <a:latin typeface="Malgun Gothic" pitchFamily="34" charset="0"/>
-                          <a:ea typeface="Malgun Gothic" pitchFamily="34" charset="-122"/>
-                          <a:cs typeface="Malgun Gothic" pitchFamily="34" charset="-120"/>
+                          <a:latin typeface="Noto Serif KR Black" pitchFamily="34" charset="0"/>
+                          <a:ea typeface="Noto Serif KR Black" pitchFamily="34" charset="-122"/>
+                          <a:cs typeface="Noto Serif KR Black" pitchFamily="34" charset="-120"/>
                         </a:rPr>
                         <a:t>하지 못한 일, 풀지 못한 관계</a:t>
                       </a:r>
                       <a:endParaRPr lang="en-US" sz="1600" dirty="0">
-                        <a:latin typeface="Malgun Gothic" charset="0"/>
-                        <a:ea typeface="Malgun Gothic" charset="0"/>
-                        <a:cs typeface="Malgun Gothic" charset="0"/>
+                        <a:latin typeface="Noto Serif KR Black" charset="0"/>
+                        <a:ea typeface="Noto Serif KR Black" charset="0"/>
+                        <a:cs typeface="Noto Serif KR Black" charset="0"/>
                       </a:endParaRPr>
                     </a:p>
                   </a:txBody>
@@ -20406,16 +20406,16 @@
                           <a:solidFill>
                             <a:srgbClr val="222222"/>
                           </a:solidFill>
-                          <a:latin typeface="Malgun Gothic" pitchFamily="34" charset="0"/>
-                          <a:ea typeface="Malgun Gothic" pitchFamily="34" charset="-122"/>
-                          <a:cs typeface="Malgun Gothic" pitchFamily="34" charset="-120"/>
+                          <a:latin typeface="Noto Serif KR Black" pitchFamily="34" charset="0"/>
+                          <a:ea typeface="Noto Serif KR Black" pitchFamily="34" charset="-122"/>
+                          <a:cs typeface="Noto Serif KR Black" pitchFamily="34" charset="-120"/>
                         </a:rPr>
                         <a:t>“아직 끝내지 못했다고 느끼는 일은 무엇인가요?”</a:t>
                       </a:r>
                       <a:endParaRPr lang="en-US" sz="1600" dirty="0">
-                        <a:latin typeface="Malgun Gothic" charset="0"/>
-                        <a:ea typeface="Malgun Gothic" charset="0"/>
-                        <a:cs typeface="Malgun Gothic" charset="0"/>
+                        <a:latin typeface="Noto Serif KR Black" charset="0"/>
+                        <a:ea typeface="Noto Serif KR Black" charset="0"/>
+                        <a:cs typeface="Noto Serif KR Black" charset="0"/>
                       </a:endParaRPr>
                     </a:p>
                   </a:txBody>
@@ -20476,16 +20476,16 @@
                           <a:solidFill>
                             <a:srgbClr val="1F4E4A"/>
                           </a:solidFill>
-                          <a:latin typeface="Malgun Gothic" pitchFamily="34" charset="0"/>
-                          <a:ea typeface="Malgun Gothic" pitchFamily="34" charset="-122"/>
-                          <a:cs typeface="Malgun Gothic" pitchFamily="34" charset="-120"/>
+                          <a:latin typeface="Noto Serif KR Black" pitchFamily="34" charset="0"/>
+                          <a:ea typeface="Noto Serif KR Black" pitchFamily="34" charset="-122"/>
+                          <a:cs typeface="Noto Serif KR Black" pitchFamily="34" charset="-120"/>
                         </a:rPr>
                         <a:t>존재소멸의 불안</a:t>
                       </a:r>
                       <a:endParaRPr lang="en-US" sz="1600" dirty="0">
-                        <a:latin typeface="Malgun Gothic" charset="0"/>
-                        <a:ea typeface="Malgun Gothic" charset="0"/>
-                        <a:cs typeface="Malgun Gothic" charset="0"/>
+                        <a:latin typeface="Noto Serif KR Black" charset="0"/>
+                        <a:ea typeface="Noto Serif KR Black" charset="0"/>
+                        <a:cs typeface="Noto Serif KR Black" charset="0"/>
                       </a:endParaRPr>
                     </a:p>
                   </a:txBody>
@@ -20544,16 +20544,16 @@
                           <a:solidFill>
                             <a:srgbClr val="222222"/>
                           </a:solidFill>
-                          <a:latin typeface="Malgun Gothic" pitchFamily="34" charset="0"/>
-                          <a:ea typeface="Malgun Gothic" pitchFamily="34" charset="-122"/>
-                          <a:cs typeface="Malgun Gothic" pitchFamily="34" charset="-120"/>
+                          <a:latin typeface="Noto Serif KR Black" pitchFamily="34" charset="0"/>
+                          <a:ea typeface="Noto Serif KR Black" pitchFamily="34" charset="-122"/>
+                          <a:cs typeface="Noto Serif KR Black" pitchFamily="34" charset="-120"/>
                         </a:rPr>
                         <a:t>내가 사라지고 잊힘</a:t>
                       </a:r>
                       <a:endParaRPr lang="en-US" sz="1600" dirty="0">
-                        <a:latin typeface="Malgun Gothic" charset="0"/>
-                        <a:ea typeface="Malgun Gothic" charset="0"/>
-                        <a:cs typeface="Malgun Gothic" charset="0"/>
+                        <a:latin typeface="Noto Serif KR Black" charset="0"/>
+                        <a:ea typeface="Noto Serif KR Black" charset="0"/>
+                        <a:cs typeface="Noto Serif KR Black" charset="0"/>
                       </a:endParaRPr>
                     </a:p>
                   </a:txBody>
@@ -20612,16 +20612,16 @@
                           <a:solidFill>
                             <a:srgbClr val="222222"/>
                           </a:solidFill>
-                          <a:latin typeface="Malgun Gothic" pitchFamily="34" charset="0"/>
-                          <a:ea typeface="Malgun Gothic" pitchFamily="34" charset="-122"/>
-                          <a:cs typeface="Malgun Gothic" pitchFamily="34" charset="-120"/>
+                          <a:latin typeface="Noto Serif KR Black" pitchFamily="34" charset="0"/>
+                          <a:ea typeface="Noto Serif KR Black" pitchFamily="34" charset="-122"/>
+                          <a:cs typeface="Noto Serif KR Black" pitchFamily="34" charset="-120"/>
                         </a:rPr>
                         <a:t>“당신의 삶에서 무엇이 남기를 바라십니까?”</a:t>
                       </a:r>
                       <a:endParaRPr lang="en-US" sz="1600" dirty="0">
-                        <a:latin typeface="Malgun Gothic" charset="0"/>
-                        <a:ea typeface="Malgun Gothic" charset="0"/>
-                        <a:cs typeface="Malgun Gothic" charset="0"/>
+                        <a:latin typeface="Noto Serif KR Black" charset="0"/>
+                        <a:ea typeface="Noto Serif KR Black" charset="0"/>
+                        <a:cs typeface="Noto Serif KR Black" charset="0"/>
                       </a:endParaRPr>
                     </a:p>
                   </a:txBody>
@@ -28086,16 +28086,16 @@
                           <a:solidFill>
                             <a:srgbClr val="FFFFFF"/>
                           </a:solidFill>
-                          <a:latin typeface="Malgun Gothic" pitchFamily="34" charset="0"/>
-                          <a:ea typeface="Malgun Gothic" pitchFamily="34" charset="-122"/>
-                          <a:cs typeface="Malgun Gothic" pitchFamily="34" charset="-120"/>
+                          <a:latin typeface="Noto Serif KR Black" pitchFamily="34" charset="0"/>
+                          <a:ea typeface="Noto Serif KR Black" pitchFamily="34" charset="-122"/>
+                          <a:cs typeface="Noto Serif KR Black" pitchFamily="34" charset="-120"/>
                         </a:rPr>
                         <a:t>원칙</a:t>
                       </a:r>
                       <a:endParaRPr lang="en-US" sz="1600" dirty="0">
-                        <a:latin typeface="Malgun Gothic" charset="0"/>
-                        <a:ea typeface="Malgun Gothic" charset="0"/>
-                        <a:cs typeface="Malgun Gothic" charset="0"/>
+                        <a:latin typeface="Noto Serif KR Black" charset="0"/>
+                        <a:ea typeface="Noto Serif KR Black" charset="0"/>
+                        <a:cs typeface="Noto Serif KR Black" charset="0"/>
                       </a:endParaRPr>
                     </a:p>
                   </a:txBody>
@@ -28154,16 +28154,16 @@
                           <a:solidFill>
                             <a:srgbClr val="FFFFFF"/>
                           </a:solidFill>
-                          <a:latin typeface="Malgun Gothic" pitchFamily="34" charset="0"/>
-                          <a:ea typeface="Malgun Gothic" pitchFamily="34" charset="-122"/>
-                          <a:cs typeface="Malgun Gothic" pitchFamily="34" charset="-120"/>
+                          <a:latin typeface="Noto Serif KR Black" pitchFamily="34" charset="0"/>
+                          <a:ea typeface="Noto Serif KR Black" pitchFamily="34" charset="-122"/>
+                          <a:cs typeface="Noto Serif KR Black" pitchFamily="34" charset="-120"/>
                         </a:rPr>
                         <a:t>의미</a:t>
                       </a:r>
                       <a:endParaRPr lang="en-US" sz="1600" dirty="0">
-                        <a:latin typeface="Malgun Gothic" charset="0"/>
-                        <a:ea typeface="Malgun Gothic" charset="0"/>
-                        <a:cs typeface="Malgun Gothic" charset="0"/>
+                        <a:latin typeface="Noto Serif KR Black" charset="0"/>
+                        <a:ea typeface="Noto Serif KR Black" charset="0"/>
+                        <a:cs typeface="Noto Serif KR Black" charset="0"/>
                       </a:endParaRPr>
                     </a:p>
                   </a:txBody>
@@ -28222,16 +28222,16 @@
                           <a:solidFill>
                             <a:srgbClr val="FFFFFF"/>
                           </a:solidFill>
-                          <a:latin typeface="Malgun Gothic" pitchFamily="34" charset="0"/>
-                          <a:ea typeface="Malgun Gothic" pitchFamily="34" charset="-122"/>
-                          <a:cs typeface="Malgun Gothic" pitchFamily="34" charset="-120"/>
+                          <a:latin typeface="Noto Serif KR Black" pitchFamily="34" charset="0"/>
+                          <a:ea typeface="Noto Serif KR Black" pitchFamily="34" charset="-122"/>
+                          <a:cs typeface="Noto Serif KR Black" pitchFamily="34" charset="-120"/>
                         </a:rPr>
                         <a:t>현장 적용</a:t>
                       </a:r>
                       <a:endParaRPr lang="en-US" sz="1600" dirty="0">
-                        <a:latin typeface="Malgun Gothic" charset="0"/>
-                        <a:ea typeface="Malgun Gothic" charset="0"/>
-                        <a:cs typeface="Malgun Gothic" charset="0"/>
+                        <a:latin typeface="Noto Serif KR Black" charset="0"/>
+                        <a:ea typeface="Noto Serif KR Black" charset="0"/>
+                        <a:cs typeface="Noto Serif KR Black" charset="0"/>
                       </a:endParaRPr>
                     </a:p>
                   </a:txBody>
@@ -28292,16 +28292,16 @@
                           <a:solidFill>
                             <a:srgbClr val="1F4E4A"/>
                           </a:solidFill>
-                          <a:latin typeface="Malgun Gothic" pitchFamily="34" charset="0"/>
-                          <a:ea typeface="Malgun Gothic" pitchFamily="34" charset="-122"/>
-                          <a:cs typeface="Malgun Gothic" pitchFamily="34" charset="-120"/>
+                          <a:latin typeface="Noto Serif KR Black" pitchFamily="34" charset="0"/>
+                          <a:ea typeface="Noto Serif KR Black" pitchFamily="34" charset="-122"/>
+                          <a:cs typeface="Noto Serif KR Black" pitchFamily="34" charset="-120"/>
                         </a:rPr>
                         <a:t>자기결정권 존중</a:t>
                       </a:r>
                       <a:endParaRPr lang="en-US" sz="1600" dirty="0">
-                        <a:latin typeface="Malgun Gothic" charset="0"/>
-                        <a:ea typeface="Malgun Gothic" charset="0"/>
-                        <a:cs typeface="Malgun Gothic" charset="0"/>
+                        <a:latin typeface="Noto Serif KR Black" charset="0"/>
+                        <a:ea typeface="Noto Serif KR Black" charset="0"/>
+                        <a:cs typeface="Noto Serif KR Black" charset="0"/>
                       </a:endParaRPr>
                     </a:p>
                   </a:txBody>
@@ -28360,16 +28360,16 @@
                           <a:solidFill>
                             <a:srgbClr val="222222"/>
                           </a:solidFill>
-                          <a:latin typeface="Malgun Gothic" pitchFamily="34" charset="0"/>
-                          <a:ea typeface="Malgun Gothic" pitchFamily="34" charset="-122"/>
-                          <a:cs typeface="Malgun Gothic" pitchFamily="34" charset="-120"/>
+                          <a:latin typeface="Noto Serif KR Black" pitchFamily="34" charset="0"/>
+                          <a:ea typeface="Noto Serif KR Black" pitchFamily="34" charset="-122"/>
+                          <a:cs typeface="Noto Serif KR Black" pitchFamily="34" charset="-120"/>
                         </a:rPr>
                         <a:t>내담자의 가치와 선택을 중심에 둔다</a:t>
                       </a:r>
                       <a:endParaRPr lang="en-US" sz="1600" dirty="0">
-                        <a:latin typeface="Malgun Gothic" charset="0"/>
-                        <a:ea typeface="Malgun Gothic" charset="0"/>
-                        <a:cs typeface="Malgun Gothic" charset="0"/>
+                        <a:latin typeface="Noto Serif KR Black" charset="0"/>
+                        <a:ea typeface="Noto Serif KR Black" charset="0"/>
+                        <a:cs typeface="Noto Serif KR Black" charset="0"/>
                       </a:endParaRPr>
                     </a:p>
                   </a:txBody>
@@ -28428,16 +28428,16 @@
                           <a:solidFill>
                             <a:srgbClr val="222222"/>
                           </a:solidFill>
-                          <a:latin typeface="Malgun Gothic" pitchFamily="34" charset="0"/>
-                          <a:ea typeface="Malgun Gothic" pitchFamily="34" charset="-122"/>
-                          <a:cs typeface="Malgun Gothic" pitchFamily="34" charset="-120"/>
+                          <a:latin typeface="Noto Serif KR Black" pitchFamily="34" charset="0"/>
+                          <a:ea typeface="Noto Serif KR Black" pitchFamily="34" charset="-122"/>
+                          <a:cs typeface="Noto Serif KR Black" pitchFamily="34" charset="-120"/>
                         </a:rPr>
                         <a:t>코치가 “좋은 선택”을 대신 결정하지 않는다</a:t>
                       </a:r>
                       <a:endParaRPr lang="en-US" sz="1600" dirty="0">
-                        <a:latin typeface="Malgun Gothic" charset="0"/>
-                        <a:ea typeface="Malgun Gothic" charset="0"/>
-                        <a:cs typeface="Malgun Gothic" charset="0"/>
+                        <a:latin typeface="Noto Serif KR Black" charset="0"/>
+                        <a:ea typeface="Noto Serif KR Black" charset="0"/>
+                        <a:cs typeface="Noto Serif KR Black" charset="0"/>
                       </a:endParaRPr>
                     </a:p>
                   </a:txBody>
@@ -28498,16 +28498,16 @@
                           <a:solidFill>
                             <a:srgbClr val="1F4E4A"/>
                           </a:solidFill>
-                          <a:latin typeface="Malgun Gothic" pitchFamily="34" charset="0"/>
-                          <a:ea typeface="Malgun Gothic" pitchFamily="34" charset="-122"/>
-                          <a:cs typeface="Malgun Gothic" pitchFamily="34" charset="-120"/>
+                          <a:latin typeface="Noto Serif KR Black" pitchFamily="34" charset="0"/>
+                          <a:ea typeface="Noto Serif KR Black" pitchFamily="34" charset="-122"/>
+                          <a:cs typeface="Noto Serif KR Black" pitchFamily="34" charset="-120"/>
                         </a:rPr>
                         <a:t>비판단</a:t>
                       </a:r>
                       <a:endParaRPr lang="en-US" sz="1600" dirty="0">
-                        <a:latin typeface="Malgun Gothic" charset="0"/>
-                        <a:ea typeface="Malgun Gothic" charset="0"/>
-                        <a:cs typeface="Malgun Gothic" charset="0"/>
+                        <a:latin typeface="Noto Serif KR Black" charset="0"/>
+                        <a:ea typeface="Noto Serif KR Black" charset="0"/>
+                        <a:cs typeface="Noto Serif KR Black" charset="0"/>
                       </a:endParaRPr>
                     </a:p>
                   </a:txBody>
@@ -28566,16 +28566,16 @@
                           <a:solidFill>
                             <a:srgbClr val="222222"/>
                           </a:solidFill>
-                          <a:latin typeface="Malgun Gothic" pitchFamily="34" charset="0"/>
-                          <a:ea typeface="Malgun Gothic" pitchFamily="34" charset="-122"/>
-                          <a:cs typeface="Malgun Gothic" pitchFamily="34" charset="-120"/>
+                          <a:latin typeface="Noto Serif KR Black" pitchFamily="34" charset="0"/>
+                          <a:ea typeface="Noto Serif KR Black" pitchFamily="34" charset="-122"/>
+                          <a:cs typeface="Noto Serif KR Black" pitchFamily="34" charset="-120"/>
                         </a:rPr>
                         <a:t>죽음관·종교·가족문화·감정을 평가하지 않는다</a:t>
                       </a:r>
                       <a:endParaRPr lang="en-US" sz="1600" dirty="0">
-                        <a:latin typeface="Malgun Gothic" charset="0"/>
-                        <a:ea typeface="Malgun Gothic" charset="0"/>
-                        <a:cs typeface="Malgun Gothic" charset="0"/>
+                        <a:latin typeface="Noto Serif KR Black" charset="0"/>
+                        <a:ea typeface="Noto Serif KR Black" charset="0"/>
+                        <a:cs typeface="Noto Serif KR Black" charset="0"/>
                       </a:endParaRPr>
                     </a:p>
                   </a:txBody>
@@ -28634,16 +28634,16 @@
                           <a:solidFill>
                             <a:srgbClr val="222222"/>
                           </a:solidFill>
-                          <a:latin typeface="Malgun Gothic" pitchFamily="34" charset="0"/>
-                          <a:ea typeface="Malgun Gothic" pitchFamily="34" charset="-122"/>
-                          <a:cs typeface="Malgun Gothic" pitchFamily="34" charset="-120"/>
+                          <a:latin typeface="Noto Serif KR Black" pitchFamily="34" charset="0"/>
+                          <a:ea typeface="Noto Serif KR Black" pitchFamily="34" charset="-122"/>
+                          <a:cs typeface="Noto Serif KR Black" pitchFamily="34" charset="-120"/>
                         </a:rPr>
                         <a:t>“왜 그렇게 생각하세요?”보다 “그 생각에는 어떤 의미가 있나요?”</a:t>
                       </a:r>
                       <a:endParaRPr lang="en-US" sz="1600" dirty="0">
-                        <a:latin typeface="Malgun Gothic" charset="0"/>
-                        <a:ea typeface="Malgun Gothic" charset="0"/>
-                        <a:cs typeface="Malgun Gothic" charset="0"/>
+                        <a:latin typeface="Noto Serif KR Black" charset="0"/>
+                        <a:ea typeface="Noto Serif KR Black" charset="0"/>
+                        <a:cs typeface="Noto Serif KR Black" charset="0"/>
                       </a:endParaRPr>
                     </a:p>
                   </a:txBody>
@@ -28704,16 +28704,16 @@
                           <a:solidFill>
                             <a:srgbClr val="1F4E4A"/>
                           </a:solidFill>
-                          <a:latin typeface="Malgun Gothic" pitchFamily="34" charset="0"/>
-                          <a:ea typeface="Malgun Gothic" pitchFamily="34" charset="-122"/>
-                          <a:cs typeface="Malgun Gothic" pitchFamily="34" charset="-120"/>
+                          <a:latin typeface="Noto Serif KR Black" pitchFamily="34" charset="0"/>
+                          <a:ea typeface="Noto Serif KR Black" pitchFamily="34" charset="-122"/>
+                          <a:cs typeface="Noto Serif KR Black" pitchFamily="34" charset="-120"/>
                         </a:rPr>
                         <a:t>중립성</a:t>
                       </a:r>
                       <a:endParaRPr lang="en-US" sz="1600" dirty="0">
-                        <a:latin typeface="Malgun Gothic" charset="0"/>
-                        <a:ea typeface="Malgun Gothic" charset="0"/>
-                        <a:cs typeface="Malgun Gothic" charset="0"/>
+                        <a:latin typeface="Noto Serif KR Black" charset="0"/>
+                        <a:ea typeface="Noto Serif KR Black" charset="0"/>
+                        <a:cs typeface="Noto Serif KR Black" charset="0"/>
                       </a:endParaRPr>
                     </a:p>
                   </a:txBody>
@@ -28772,16 +28772,16 @@
                           <a:solidFill>
                             <a:srgbClr val="222222"/>
                           </a:solidFill>
-                          <a:latin typeface="Malgun Gothic" pitchFamily="34" charset="0"/>
-                          <a:ea typeface="Malgun Gothic" pitchFamily="34" charset="-122"/>
-                          <a:cs typeface="Malgun Gothic" pitchFamily="34" charset="-120"/>
+                          <a:latin typeface="Noto Serif KR Black" pitchFamily="34" charset="0"/>
+                          <a:ea typeface="Noto Serif KR Black" pitchFamily="34" charset="-122"/>
+                          <a:cs typeface="Noto Serif KR Black" pitchFamily="34" charset="-120"/>
                         </a:rPr>
                         <a:t>개인의 종교·윤리·장례관을 강요하지 않는다</a:t>
                       </a:r>
                       <a:endParaRPr lang="en-US" sz="1600" dirty="0">
-                        <a:latin typeface="Malgun Gothic" charset="0"/>
-                        <a:ea typeface="Malgun Gothic" charset="0"/>
-                        <a:cs typeface="Malgun Gothic" charset="0"/>
+                        <a:latin typeface="Noto Serif KR Black" charset="0"/>
+                        <a:ea typeface="Noto Serif KR Black" charset="0"/>
+                        <a:cs typeface="Noto Serif KR Black" charset="0"/>
                       </a:endParaRPr>
                     </a:p>
                   </a:txBody>
@@ -28840,16 +28840,16 @@
                           <a:solidFill>
                             <a:srgbClr val="222222"/>
                           </a:solidFill>
-                          <a:latin typeface="Malgun Gothic" pitchFamily="34" charset="0"/>
-                          <a:ea typeface="Malgun Gothic" pitchFamily="34" charset="-122"/>
-                          <a:cs typeface="Malgun Gothic" pitchFamily="34" charset="-120"/>
+                          <a:latin typeface="Noto Serif KR Black" pitchFamily="34" charset="0"/>
+                          <a:ea typeface="Noto Serif KR Black" pitchFamily="34" charset="-122"/>
+                          <a:cs typeface="Noto Serif KR Black" pitchFamily="34" charset="-120"/>
                         </a:rPr>
                         <a:t>정보를 주되 특정 선택으로 몰아가지 않는다</a:t>
                       </a:r>
                       <a:endParaRPr lang="en-US" sz="1600" dirty="0">
-                        <a:latin typeface="Malgun Gothic" charset="0"/>
-                        <a:ea typeface="Malgun Gothic" charset="0"/>
-                        <a:cs typeface="Malgun Gothic" charset="0"/>
+                        <a:latin typeface="Noto Serif KR Black" charset="0"/>
+                        <a:ea typeface="Noto Serif KR Black" charset="0"/>
+                        <a:cs typeface="Noto Serif KR Black" charset="0"/>
                       </a:endParaRPr>
                     </a:p>
                   </a:txBody>
@@ -28910,16 +28910,16 @@
                           <a:solidFill>
                             <a:srgbClr val="1F4E4A"/>
                           </a:solidFill>
-                          <a:latin typeface="Malgun Gothic" pitchFamily="34" charset="0"/>
-                          <a:ea typeface="Malgun Gothic" pitchFamily="34" charset="-122"/>
-                          <a:cs typeface="Malgun Gothic" pitchFamily="34" charset="-120"/>
+                          <a:latin typeface="Noto Serif KR Black" pitchFamily="34" charset="0"/>
+                          <a:ea typeface="Noto Serif KR Black" pitchFamily="34" charset="-122"/>
+                          <a:cs typeface="Noto Serif KR Black" pitchFamily="34" charset="-120"/>
                         </a:rPr>
                         <a:t>정확한 정보</a:t>
                       </a:r>
                       <a:endParaRPr lang="en-US" sz="1600" dirty="0">
-                        <a:latin typeface="Malgun Gothic" charset="0"/>
-                        <a:ea typeface="Malgun Gothic" charset="0"/>
-                        <a:cs typeface="Malgun Gothic" charset="0"/>
+                        <a:latin typeface="Noto Serif KR Black" charset="0"/>
+                        <a:ea typeface="Noto Serif KR Black" charset="0"/>
+                        <a:cs typeface="Noto Serif KR Black" charset="0"/>
                       </a:endParaRPr>
                     </a:p>
                   </a:txBody>
@@ -28978,16 +28978,16 @@
                           <a:solidFill>
                             <a:srgbClr val="222222"/>
                           </a:solidFill>
-                          <a:latin typeface="Malgun Gothic" pitchFamily="34" charset="0"/>
-                          <a:ea typeface="Malgun Gothic" pitchFamily="34" charset="-122"/>
-                          <a:cs typeface="Malgun Gothic" pitchFamily="34" charset="-120"/>
+                          <a:latin typeface="Noto Serif KR Black" pitchFamily="34" charset="0"/>
+                          <a:ea typeface="Noto Serif KR Black" pitchFamily="34" charset="-122"/>
+                          <a:cs typeface="Noto Serif KR Black" pitchFamily="34" charset="-120"/>
                         </a:rPr>
                         <a:t>의료·법률·장례 정보를 추측하지 않는다</a:t>
                       </a:r>
                       <a:endParaRPr lang="en-US" sz="1600" dirty="0">
-                        <a:latin typeface="Malgun Gothic" charset="0"/>
-                        <a:ea typeface="Malgun Gothic" charset="0"/>
-                        <a:cs typeface="Malgun Gothic" charset="0"/>
+                        <a:latin typeface="Noto Serif KR Black" charset="0"/>
+                        <a:ea typeface="Noto Serif KR Black" charset="0"/>
+                        <a:cs typeface="Noto Serif KR Black" charset="0"/>
                       </a:endParaRPr>
                     </a:p>
                   </a:txBody>
@@ -29046,16 +29046,16 @@
                           <a:solidFill>
                             <a:srgbClr val="222222"/>
                           </a:solidFill>
-                          <a:latin typeface="Malgun Gothic" pitchFamily="34" charset="0"/>
-                          <a:ea typeface="Malgun Gothic" pitchFamily="34" charset="-122"/>
-                          <a:cs typeface="Malgun Gothic" pitchFamily="34" charset="-120"/>
+                          <a:latin typeface="Noto Serif KR Black" pitchFamily="34" charset="0"/>
+                          <a:ea typeface="Noto Serif KR Black" pitchFamily="34" charset="-122"/>
+                          <a:cs typeface="Noto Serif KR Black" pitchFamily="34" charset="-120"/>
                         </a:rPr>
                         <a:t>변경 가능성이 큰 정보는 공식기관 최신자료 확인</a:t>
                       </a:r>
                       <a:endParaRPr lang="en-US" sz="1600" dirty="0">
-                        <a:latin typeface="Malgun Gothic" charset="0"/>
-                        <a:ea typeface="Malgun Gothic" charset="0"/>
-                        <a:cs typeface="Malgun Gothic" charset="0"/>
+                        <a:latin typeface="Noto Serif KR Black" charset="0"/>
+                        <a:ea typeface="Noto Serif KR Black" charset="0"/>
+                        <a:cs typeface="Noto Serif KR Black" charset="0"/>
                       </a:endParaRPr>
                     </a:p>
                   </a:txBody>
@@ -29116,16 +29116,16 @@
                           <a:solidFill>
                             <a:srgbClr val="1F4E4A"/>
                           </a:solidFill>
-                          <a:latin typeface="Malgun Gothic" pitchFamily="34" charset="0"/>
-                          <a:ea typeface="Malgun Gothic" pitchFamily="34" charset="-122"/>
-                          <a:cs typeface="Malgun Gothic" pitchFamily="34" charset="-120"/>
+                          <a:latin typeface="Noto Serif KR Black" pitchFamily="34" charset="0"/>
+                          <a:ea typeface="Noto Serif KR Black" pitchFamily="34" charset="-122"/>
+                          <a:cs typeface="Noto Serif KR Black" pitchFamily="34" charset="-120"/>
                         </a:rPr>
                         <a:t>전문가 연계</a:t>
                       </a:r>
                       <a:endParaRPr lang="en-US" sz="1600" dirty="0">
-                        <a:latin typeface="Malgun Gothic" charset="0"/>
-                        <a:ea typeface="Malgun Gothic" charset="0"/>
-                        <a:cs typeface="Malgun Gothic" charset="0"/>
+                        <a:latin typeface="Noto Serif KR Black" charset="0"/>
+                        <a:ea typeface="Noto Serif KR Black" charset="0"/>
+                        <a:cs typeface="Noto Serif KR Black" charset="0"/>
                       </a:endParaRPr>
                     </a:p>
                   </a:txBody>
@@ -29184,16 +29184,16 @@
                           <a:solidFill>
                             <a:srgbClr val="222222"/>
                           </a:solidFill>
-                          <a:latin typeface="Malgun Gothic" pitchFamily="34" charset="0"/>
-                          <a:ea typeface="Malgun Gothic" pitchFamily="34" charset="-122"/>
-                          <a:cs typeface="Malgun Gothic" pitchFamily="34" charset="-120"/>
+                          <a:latin typeface="Noto Serif KR Black" pitchFamily="34" charset="0"/>
+                          <a:ea typeface="Noto Serif KR Black" pitchFamily="34" charset="-122"/>
+                          <a:cs typeface="Noto Serif KR Black" pitchFamily="34" charset="-120"/>
                         </a:rPr>
                         <a:t>역할 밖 문제는 전문가에게 연결한다</a:t>
                       </a:r>
                       <a:endParaRPr lang="en-US" sz="1600" dirty="0">
-                        <a:latin typeface="Malgun Gothic" charset="0"/>
-                        <a:ea typeface="Malgun Gothic" charset="0"/>
-                        <a:cs typeface="Malgun Gothic" charset="0"/>
+                        <a:latin typeface="Noto Serif KR Black" charset="0"/>
+                        <a:ea typeface="Noto Serif KR Black" charset="0"/>
+                        <a:cs typeface="Noto Serif KR Black" charset="0"/>
                       </a:endParaRPr>
                     </a:p>
                   </a:txBody>
@@ -29252,16 +29252,16 @@
                           <a:solidFill>
                             <a:srgbClr val="222222"/>
                           </a:solidFill>
-                          <a:latin typeface="Malgun Gothic" pitchFamily="34" charset="0"/>
-                          <a:ea typeface="Malgun Gothic" pitchFamily="34" charset="-122"/>
-                          <a:cs typeface="Malgun Gothic" pitchFamily="34" charset="-120"/>
+                          <a:latin typeface="Noto Serif KR Black" pitchFamily="34" charset="0"/>
+                          <a:ea typeface="Noto Serif KR Black" pitchFamily="34" charset="-122"/>
+                          <a:cs typeface="Noto Serif KR Black" pitchFamily="34" charset="-120"/>
                         </a:rPr>
                         <a:t>의료판단·법률자문·심리치료·세무·투자는 하지 않는다</a:t>
                       </a:r>
                       <a:endParaRPr lang="en-US" sz="1600" dirty="0">
-                        <a:latin typeface="Malgun Gothic" charset="0"/>
-                        <a:ea typeface="Malgun Gothic" charset="0"/>
-                        <a:cs typeface="Malgun Gothic" charset="0"/>
+                        <a:latin typeface="Noto Serif KR Black" charset="0"/>
+                        <a:ea typeface="Noto Serif KR Black" charset="0"/>
+                        <a:cs typeface="Noto Serif KR Black" charset="0"/>
                       </a:endParaRPr>
                     </a:p>
                   </a:txBody>
@@ -34289,16 +34289,16 @@
                           <a:solidFill>
                             <a:srgbClr val="FFFFFF"/>
                           </a:solidFill>
-                          <a:latin typeface="Malgun Gothic" pitchFamily="34" charset="0"/>
-                          <a:ea typeface="Malgun Gothic" pitchFamily="34" charset="-122"/>
-                          <a:cs typeface="Malgun Gothic" pitchFamily="34" charset="-120"/>
+                          <a:latin typeface="Noto Serif KR Black" pitchFamily="34" charset="0"/>
+                          <a:ea typeface="Noto Serif KR Black" pitchFamily="34" charset="-122"/>
+                          <a:cs typeface="Noto Serif KR Black" pitchFamily="34" charset="-120"/>
                         </a:rPr>
                         <a:t>번호</a:t>
                       </a:r>
                       <a:endParaRPr lang="en-US" sz="1500" dirty="0">
-                        <a:latin typeface="Malgun Gothic" charset="0"/>
-                        <a:ea typeface="Malgun Gothic" charset="0"/>
-                        <a:cs typeface="Malgun Gothic" charset="0"/>
+                        <a:latin typeface="Noto Serif KR Black" charset="0"/>
+                        <a:ea typeface="Noto Serif KR Black" charset="0"/>
+                        <a:cs typeface="Noto Serif KR Black" charset="0"/>
                       </a:endParaRPr>
                     </a:p>
                   </a:txBody>
@@ -34357,16 +34357,16 @@
                           <a:solidFill>
                             <a:srgbClr val="FFFFFF"/>
                           </a:solidFill>
-                          <a:latin typeface="Malgun Gothic" pitchFamily="34" charset="0"/>
-                          <a:ea typeface="Malgun Gothic" pitchFamily="34" charset="-122"/>
-                          <a:cs typeface="Malgun Gothic" pitchFamily="34" charset="-120"/>
+                          <a:latin typeface="Noto Serif KR Black" pitchFamily="34" charset="0"/>
+                          <a:ea typeface="Noto Serif KR Black" pitchFamily="34" charset="-122"/>
+                          <a:cs typeface="Noto Serif KR Black" pitchFamily="34" charset="-120"/>
                         </a:rPr>
                         <a:t>점검 문항</a:t>
                       </a:r>
                       <a:endParaRPr lang="en-US" sz="1500" dirty="0">
-                        <a:latin typeface="Malgun Gothic" charset="0"/>
-                        <a:ea typeface="Malgun Gothic" charset="0"/>
-                        <a:cs typeface="Malgun Gothic" charset="0"/>
+                        <a:latin typeface="Noto Serif KR Black" charset="0"/>
+                        <a:ea typeface="Noto Serif KR Black" charset="0"/>
+                        <a:cs typeface="Noto Serif KR Black" charset="0"/>
                       </a:endParaRPr>
                     </a:p>
                   </a:txBody>
@@ -34425,16 +34425,16 @@
                           <a:solidFill>
                             <a:srgbClr val="FFFFFF"/>
                           </a:solidFill>
-                          <a:latin typeface="Malgun Gothic" pitchFamily="34" charset="0"/>
-                          <a:ea typeface="Malgun Gothic" pitchFamily="34" charset="-122"/>
-                          <a:cs typeface="Malgun Gothic" pitchFamily="34" charset="-120"/>
+                          <a:latin typeface="Noto Serif KR Black" pitchFamily="34" charset="0"/>
+                          <a:ea typeface="Noto Serif KR Black" pitchFamily="34" charset="-122"/>
+                          <a:cs typeface="Noto Serif KR Black" pitchFamily="34" charset="-120"/>
                         </a:rPr>
                         <a:t>점수</a:t>
                       </a:r>
                       <a:endParaRPr lang="en-US" sz="1500" dirty="0">
-                        <a:latin typeface="Malgun Gothic" charset="0"/>
-                        <a:ea typeface="Malgun Gothic" charset="0"/>
-                        <a:cs typeface="Malgun Gothic" charset="0"/>
+                        <a:latin typeface="Noto Serif KR Black" charset="0"/>
+                        <a:ea typeface="Noto Serif KR Black" charset="0"/>
+                        <a:cs typeface="Noto Serif KR Black" charset="0"/>
                       </a:endParaRPr>
                     </a:p>
                   </a:txBody>
@@ -34495,16 +34495,16 @@
                           <a:solidFill>
                             <a:srgbClr val="1F4E4A"/>
                           </a:solidFill>
-                          <a:latin typeface="Malgun Gothic" pitchFamily="34" charset="0"/>
-                          <a:ea typeface="Malgun Gothic" pitchFamily="34" charset="-122"/>
-                          <a:cs typeface="Malgun Gothic" pitchFamily="34" charset="-120"/>
+                          <a:latin typeface="Noto Serif KR Black" pitchFamily="34" charset="0"/>
+                          <a:ea typeface="Noto Serif KR Black" pitchFamily="34" charset="-122"/>
+                          <a:cs typeface="Noto Serif KR Black" pitchFamily="34" charset="-120"/>
                         </a:rPr>
                         <a:t>1</a:t>
                       </a:r>
                       <a:endParaRPr lang="en-US" sz="1500" dirty="0">
-                        <a:latin typeface="Malgun Gothic" charset="0"/>
-                        <a:ea typeface="Malgun Gothic" charset="0"/>
-                        <a:cs typeface="Malgun Gothic" charset="0"/>
+                        <a:latin typeface="Noto Serif KR Black" charset="0"/>
+                        <a:ea typeface="Noto Serif KR Black" charset="0"/>
+                        <a:cs typeface="Noto Serif KR Black" charset="0"/>
                       </a:endParaRPr>
                     </a:p>
                   </a:txBody>
@@ -34563,16 +34563,16 @@
                           <a:solidFill>
                             <a:srgbClr val="222222"/>
                           </a:solidFill>
-                          <a:latin typeface="Malgun Gothic" pitchFamily="34" charset="0"/>
-                          <a:ea typeface="Malgun Gothic" pitchFamily="34" charset="-122"/>
-                          <a:cs typeface="Malgun Gothic" pitchFamily="34" charset="-120"/>
+                          <a:latin typeface="Noto Serif KR Black" pitchFamily="34" charset="0"/>
+                          <a:ea typeface="Noto Serif KR Black" pitchFamily="34" charset="-122"/>
+                          <a:cs typeface="Noto Serif KR Black" pitchFamily="34" charset="-120"/>
                         </a:rPr>
                         <a:t>나는 죽음에 대해 비교적 편안하게 이야기할 수 있다.</a:t>
                       </a:r>
                       <a:endParaRPr lang="en-US" sz="1500" dirty="0">
-                        <a:latin typeface="Malgun Gothic" charset="0"/>
-                        <a:ea typeface="Malgun Gothic" charset="0"/>
-                        <a:cs typeface="Malgun Gothic" charset="0"/>
+                        <a:latin typeface="Noto Serif KR Black" charset="0"/>
+                        <a:ea typeface="Noto Serif KR Black" charset="0"/>
+                        <a:cs typeface="Noto Serif KR Black" charset="0"/>
                       </a:endParaRPr>
                     </a:p>
                   </a:txBody>
@@ -34631,16 +34631,16 @@
                           <a:solidFill>
                             <a:srgbClr val="222222"/>
                           </a:solidFill>
-                          <a:latin typeface="Malgun Gothic" pitchFamily="34" charset="0"/>
-                          <a:ea typeface="Malgun Gothic" pitchFamily="34" charset="-122"/>
-                          <a:cs typeface="Malgun Gothic" pitchFamily="34" charset="-120"/>
+                          <a:latin typeface="Noto Serif KR Black" pitchFamily="34" charset="0"/>
+                          <a:ea typeface="Noto Serif KR Black" pitchFamily="34" charset="-122"/>
+                          <a:cs typeface="Noto Serif KR Black" pitchFamily="34" charset="-120"/>
                         </a:rPr>
                         <a:t>1  2  3  4  5</a:t>
                       </a:r>
                       <a:endParaRPr lang="en-US" sz="1500" dirty="0">
-                        <a:latin typeface="Malgun Gothic" charset="0"/>
-                        <a:ea typeface="Malgun Gothic" charset="0"/>
-                        <a:cs typeface="Malgun Gothic" charset="0"/>
+                        <a:latin typeface="Noto Serif KR Black" charset="0"/>
+                        <a:ea typeface="Noto Serif KR Black" charset="0"/>
+                        <a:cs typeface="Noto Serif KR Black" charset="0"/>
                       </a:endParaRPr>
                     </a:p>
                   </a:txBody>
@@ -34701,16 +34701,16 @@
                           <a:solidFill>
                             <a:srgbClr val="1F4E4A"/>
                           </a:solidFill>
-                          <a:latin typeface="Malgun Gothic" pitchFamily="34" charset="0"/>
-                          <a:ea typeface="Malgun Gothic" pitchFamily="34" charset="-122"/>
-                          <a:cs typeface="Malgun Gothic" pitchFamily="34" charset="-120"/>
+                          <a:latin typeface="Noto Serif KR Black" pitchFamily="34" charset="0"/>
+                          <a:ea typeface="Noto Serif KR Black" pitchFamily="34" charset="-122"/>
+                          <a:cs typeface="Noto Serif KR Black" pitchFamily="34" charset="-120"/>
                         </a:rPr>
                         <a:t>2</a:t>
                       </a:r>
                       <a:endParaRPr lang="en-US" sz="1500" dirty="0">
-                        <a:latin typeface="Malgun Gothic" charset="0"/>
-                        <a:ea typeface="Malgun Gothic" charset="0"/>
-                        <a:cs typeface="Malgun Gothic" charset="0"/>
+                        <a:latin typeface="Noto Serif KR Black" charset="0"/>
+                        <a:ea typeface="Noto Serif KR Black" charset="0"/>
+                        <a:cs typeface="Noto Serif KR Black" charset="0"/>
                       </a:endParaRPr>
                     </a:p>
                   </a:txBody>
@@ -34769,16 +34769,16 @@
                           <a:solidFill>
                             <a:srgbClr val="222222"/>
                           </a:solidFill>
-                          <a:latin typeface="Malgun Gothic" pitchFamily="34" charset="0"/>
-                          <a:ea typeface="Malgun Gothic" pitchFamily="34" charset="-122"/>
-                          <a:cs typeface="Malgun Gothic" pitchFamily="34" charset="-120"/>
+                          <a:latin typeface="Noto Serif KR Black" pitchFamily="34" charset="0"/>
+                          <a:ea typeface="Noto Serif KR Black" pitchFamily="34" charset="-122"/>
+                          <a:cs typeface="Noto Serif KR Black" pitchFamily="34" charset="-120"/>
                         </a:rPr>
                         <a:t>죽음을 생각하면 막연한 불안이 생긴다.</a:t>
                       </a:r>
                       <a:endParaRPr lang="en-US" sz="1500" dirty="0">
-                        <a:latin typeface="Malgun Gothic" charset="0"/>
-                        <a:ea typeface="Malgun Gothic" charset="0"/>
-                        <a:cs typeface="Malgun Gothic" charset="0"/>
+                        <a:latin typeface="Noto Serif KR Black" charset="0"/>
+                        <a:ea typeface="Noto Serif KR Black" charset="0"/>
+                        <a:cs typeface="Noto Serif KR Black" charset="0"/>
                       </a:endParaRPr>
                     </a:p>
                   </a:txBody>
@@ -34837,16 +34837,16 @@
                           <a:solidFill>
                             <a:srgbClr val="222222"/>
                           </a:solidFill>
-                          <a:latin typeface="Malgun Gothic" pitchFamily="34" charset="0"/>
-                          <a:ea typeface="Malgun Gothic" pitchFamily="34" charset="-122"/>
-                          <a:cs typeface="Malgun Gothic" pitchFamily="34" charset="-120"/>
+                          <a:latin typeface="Noto Serif KR Black" pitchFamily="34" charset="0"/>
+                          <a:ea typeface="Noto Serif KR Black" pitchFamily="34" charset="-122"/>
+                          <a:cs typeface="Noto Serif KR Black" pitchFamily="34" charset="-120"/>
                         </a:rPr>
                         <a:t>1  2  3  4  5</a:t>
                       </a:r>
                       <a:endParaRPr lang="en-US" sz="1500" dirty="0">
-                        <a:latin typeface="Malgun Gothic" charset="0"/>
-                        <a:ea typeface="Malgun Gothic" charset="0"/>
-                        <a:cs typeface="Malgun Gothic" charset="0"/>
+                        <a:latin typeface="Noto Serif KR Black" charset="0"/>
+                        <a:ea typeface="Noto Serif KR Black" charset="0"/>
+                        <a:cs typeface="Noto Serif KR Black" charset="0"/>
                       </a:endParaRPr>
                     </a:p>
                   </a:txBody>
@@ -34907,16 +34907,16 @@
                           <a:solidFill>
                             <a:srgbClr val="1F4E4A"/>
                           </a:solidFill>
-                          <a:latin typeface="Malgun Gothic" pitchFamily="34" charset="0"/>
-                          <a:ea typeface="Malgun Gothic" pitchFamily="34" charset="-122"/>
-                          <a:cs typeface="Malgun Gothic" pitchFamily="34" charset="-120"/>
+                          <a:latin typeface="Noto Serif KR Black" pitchFamily="34" charset="0"/>
+                          <a:ea typeface="Noto Serif KR Black" pitchFamily="34" charset="-122"/>
+                          <a:cs typeface="Noto Serif KR Black" pitchFamily="34" charset="-120"/>
                         </a:rPr>
                         <a:t>3</a:t>
                       </a:r>
                       <a:endParaRPr lang="en-US" sz="1500" dirty="0">
-                        <a:latin typeface="Malgun Gothic" charset="0"/>
-                        <a:ea typeface="Malgun Gothic" charset="0"/>
-                        <a:cs typeface="Malgun Gothic" charset="0"/>
+                        <a:latin typeface="Noto Serif KR Black" charset="0"/>
+                        <a:ea typeface="Noto Serif KR Black" charset="0"/>
+                        <a:cs typeface="Noto Serif KR Black" charset="0"/>
                       </a:endParaRPr>
                     </a:p>
                   </a:txBody>
@@ -34975,16 +34975,16 @@
                           <a:solidFill>
                             <a:srgbClr val="222222"/>
                           </a:solidFill>
-                          <a:latin typeface="Malgun Gothic" pitchFamily="34" charset="0"/>
-                          <a:ea typeface="Malgun Gothic" pitchFamily="34" charset="-122"/>
-                          <a:cs typeface="Malgun Gothic" pitchFamily="34" charset="-120"/>
+                          <a:latin typeface="Noto Serif KR Black" pitchFamily="34" charset="0"/>
+                          <a:ea typeface="Noto Serif KR Black" pitchFamily="34" charset="-122"/>
+                          <a:cs typeface="Noto Serif KR Black" pitchFamily="34" charset="-120"/>
                         </a:rPr>
                         <a:t>가족과 나의 죽음에 대해 이야기해 본 적이 있다.</a:t>
                       </a:r>
                       <a:endParaRPr lang="en-US" sz="1500" dirty="0">
-                        <a:latin typeface="Malgun Gothic" charset="0"/>
-                        <a:ea typeface="Malgun Gothic" charset="0"/>
-                        <a:cs typeface="Malgun Gothic" charset="0"/>
+                        <a:latin typeface="Noto Serif KR Black" charset="0"/>
+                        <a:ea typeface="Noto Serif KR Black" charset="0"/>
+                        <a:cs typeface="Noto Serif KR Black" charset="0"/>
                       </a:endParaRPr>
                     </a:p>
                   </a:txBody>
@@ -35043,16 +35043,16 @@
                           <a:solidFill>
                             <a:srgbClr val="222222"/>
                           </a:solidFill>
-                          <a:latin typeface="Malgun Gothic" pitchFamily="34" charset="0"/>
-                          <a:ea typeface="Malgun Gothic" pitchFamily="34" charset="-122"/>
-                          <a:cs typeface="Malgun Gothic" pitchFamily="34" charset="-120"/>
+                          <a:latin typeface="Noto Serif KR Black" pitchFamily="34" charset="0"/>
+                          <a:ea typeface="Noto Serif KR Black" pitchFamily="34" charset="-122"/>
+                          <a:cs typeface="Noto Serif KR Black" pitchFamily="34" charset="-120"/>
                         </a:rPr>
                         <a:t>1  2  3  4  5</a:t>
                       </a:r>
                       <a:endParaRPr lang="en-US" sz="1500" dirty="0">
-                        <a:latin typeface="Malgun Gothic" charset="0"/>
-                        <a:ea typeface="Malgun Gothic" charset="0"/>
-                        <a:cs typeface="Malgun Gothic" charset="0"/>
+                        <a:latin typeface="Noto Serif KR Black" charset="0"/>
+                        <a:ea typeface="Noto Serif KR Black" charset="0"/>
+                        <a:cs typeface="Noto Serif KR Black" charset="0"/>
                       </a:endParaRPr>
                     </a:p>
                   </a:txBody>
@@ -35113,16 +35113,16 @@
                           <a:solidFill>
                             <a:srgbClr val="1F4E4A"/>
                           </a:solidFill>
-                          <a:latin typeface="Malgun Gothic" pitchFamily="34" charset="0"/>
-                          <a:ea typeface="Malgun Gothic" pitchFamily="34" charset="-122"/>
-                          <a:cs typeface="Malgun Gothic" pitchFamily="34" charset="-120"/>
+                          <a:latin typeface="Noto Serif KR Black" pitchFamily="34" charset="0"/>
+                          <a:ea typeface="Noto Serif KR Black" pitchFamily="34" charset="-122"/>
+                          <a:cs typeface="Noto Serif KR Black" pitchFamily="34" charset="-120"/>
                         </a:rPr>
                         <a:t>4</a:t>
                       </a:r>
                       <a:endParaRPr lang="en-US" sz="1500" dirty="0">
-                        <a:latin typeface="Malgun Gothic" charset="0"/>
-                        <a:ea typeface="Malgun Gothic" charset="0"/>
-                        <a:cs typeface="Malgun Gothic" charset="0"/>
+                        <a:latin typeface="Noto Serif KR Black" charset="0"/>
+                        <a:ea typeface="Noto Serif KR Black" charset="0"/>
+                        <a:cs typeface="Noto Serif KR Black" charset="0"/>
                       </a:endParaRPr>
                     </a:p>
                   </a:txBody>
@@ -35181,16 +35181,16 @@
                           <a:solidFill>
                             <a:srgbClr val="222222"/>
                           </a:solidFill>
-                          <a:latin typeface="Malgun Gothic" pitchFamily="34" charset="0"/>
-                          <a:ea typeface="Malgun Gothic" pitchFamily="34" charset="-122"/>
-                          <a:cs typeface="Malgun Gothic" pitchFamily="34" charset="-120"/>
+                          <a:latin typeface="Noto Serif KR Black" pitchFamily="34" charset="0"/>
+                          <a:ea typeface="Noto Serif KR Black" pitchFamily="34" charset="-122"/>
+                          <a:cs typeface="Noto Serif KR Black" pitchFamily="34" charset="-120"/>
                         </a:rPr>
                         <a:t>내가 원하는 마지막 모습에 대해 생각해 본 적이 있다.</a:t>
                       </a:r>
                       <a:endParaRPr lang="en-US" sz="1500" dirty="0">
-                        <a:latin typeface="Malgun Gothic" charset="0"/>
-                        <a:ea typeface="Malgun Gothic" charset="0"/>
-                        <a:cs typeface="Malgun Gothic" charset="0"/>
+                        <a:latin typeface="Noto Serif KR Black" charset="0"/>
+                        <a:ea typeface="Noto Serif KR Black" charset="0"/>
+                        <a:cs typeface="Noto Serif KR Black" charset="0"/>
                       </a:endParaRPr>
                     </a:p>
                   </a:txBody>
@@ -35249,16 +35249,16 @@
                           <a:solidFill>
                             <a:srgbClr val="222222"/>
                           </a:solidFill>
-                          <a:latin typeface="Malgun Gothic" pitchFamily="34" charset="0"/>
-                          <a:ea typeface="Malgun Gothic" pitchFamily="34" charset="-122"/>
-                          <a:cs typeface="Malgun Gothic" pitchFamily="34" charset="-120"/>
+                          <a:latin typeface="Noto Serif KR Black" pitchFamily="34" charset="0"/>
+                          <a:ea typeface="Noto Serif KR Black" pitchFamily="34" charset="-122"/>
+                          <a:cs typeface="Noto Serif KR Black" pitchFamily="34" charset="-120"/>
                         </a:rPr>
                         <a:t>1  2  3  4  5</a:t>
                       </a:r>
                       <a:endParaRPr lang="en-US" sz="1500" dirty="0">
-                        <a:latin typeface="Malgun Gothic" charset="0"/>
-                        <a:ea typeface="Malgun Gothic" charset="0"/>
-                        <a:cs typeface="Malgun Gothic" charset="0"/>
+                        <a:latin typeface="Noto Serif KR Black" charset="0"/>
+                        <a:ea typeface="Noto Serif KR Black" charset="0"/>
+                        <a:cs typeface="Noto Serif KR Black" charset="0"/>
                       </a:endParaRPr>
                     </a:p>
                   </a:txBody>
@@ -35319,16 +35319,16 @@
                           <a:solidFill>
                             <a:srgbClr val="1F4E4A"/>
                           </a:solidFill>
-                          <a:latin typeface="Malgun Gothic" pitchFamily="34" charset="0"/>
-                          <a:ea typeface="Malgun Gothic" pitchFamily="34" charset="-122"/>
-                          <a:cs typeface="Malgun Gothic" pitchFamily="34" charset="-120"/>
+                          <a:latin typeface="Noto Serif KR Black" pitchFamily="34" charset="0"/>
+                          <a:ea typeface="Noto Serif KR Black" pitchFamily="34" charset="-122"/>
+                          <a:cs typeface="Noto Serif KR Black" pitchFamily="34" charset="-120"/>
                         </a:rPr>
                         <a:t>5</a:t>
                       </a:r>
                       <a:endParaRPr lang="en-US" sz="1500" dirty="0">
-                        <a:latin typeface="Malgun Gothic" charset="0"/>
-                        <a:ea typeface="Malgun Gothic" charset="0"/>
-                        <a:cs typeface="Malgun Gothic" charset="0"/>
+                        <a:latin typeface="Noto Serif KR Black" charset="0"/>
+                        <a:ea typeface="Noto Serif KR Black" charset="0"/>
+                        <a:cs typeface="Noto Serif KR Black" charset="0"/>
                       </a:endParaRPr>
                     </a:p>
                   </a:txBody>
@@ -35387,16 +35387,16 @@
                           <a:solidFill>
                             <a:srgbClr val="222222"/>
                           </a:solidFill>
-                          <a:latin typeface="Malgun Gothic" pitchFamily="34" charset="0"/>
-                          <a:ea typeface="Malgun Gothic" pitchFamily="34" charset="-122"/>
-                          <a:cs typeface="Malgun Gothic" pitchFamily="34" charset="-120"/>
+                          <a:latin typeface="Noto Serif KR Black" pitchFamily="34" charset="0"/>
+                          <a:ea typeface="Noto Serif KR Black" pitchFamily="34" charset="-122"/>
+                          <a:cs typeface="Noto Serif KR Black" pitchFamily="34" charset="-120"/>
                         </a:rPr>
                         <a:t>장례방식에 대해 생각해 본 적이 있다.</a:t>
                       </a:r>
                       <a:endParaRPr lang="en-US" sz="1500" dirty="0">
-                        <a:latin typeface="Malgun Gothic" charset="0"/>
-                        <a:ea typeface="Malgun Gothic" charset="0"/>
-                        <a:cs typeface="Malgun Gothic" charset="0"/>
+                        <a:latin typeface="Noto Serif KR Black" charset="0"/>
+                        <a:ea typeface="Noto Serif KR Black" charset="0"/>
+                        <a:cs typeface="Noto Serif KR Black" charset="0"/>
                       </a:endParaRPr>
                     </a:p>
                   </a:txBody>
@@ -35455,16 +35455,16 @@
                           <a:solidFill>
                             <a:srgbClr val="222222"/>
                           </a:solidFill>
-                          <a:latin typeface="Malgun Gothic" pitchFamily="34" charset="0"/>
-                          <a:ea typeface="Malgun Gothic" pitchFamily="34" charset="-122"/>
-                          <a:cs typeface="Malgun Gothic" pitchFamily="34" charset="-120"/>
+                          <a:latin typeface="Noto Serif KR Black" pitchFamily="34" charset="0"/>
+                          <a:ea typeface="Noto Serif KR Black" pitchFamily="34" charset="-122"/>
+                          <a:cs typeface="Noto Serif KR Black" pitchFamily="34" charset="-120"/>
                         </a:rPr>
                         <a:t>1  2  3  4  5</a:t>
                       </a:r>
                       <a:endParaRPr lang="en-US" sz="1500" dirty="0">
-                        <a:latin typeface="Malgun Gothic" charset="0"/>
-                        <a:ea typeface="Malgun Gothic" charset="0"/>
-                        <a:cs typeface="Malgun Gothic" charset="0"/>
+                        <a:latin typeface="Noto Serif KR Black" charset="0"/>
+                        <a:ea typeface="Noto Serif KR Black" charset="0"/>
+                        <a:cs typeface="Noto Serif KR Black" charset="0"/>
                       </a:endParaRPr>
                     </a:p>
                   </a:txBody>
@@ -35525,16 +35525,16 @@
                           <a:solidFill>
                             <a:srgbClr val="1F4E4A"/>
                           </a:solidFill>
-                          <a:latin typeface="Malgun Gothic" pitchFamily="34" charset="0"/>
-                          <a:ea typeface="Malgun Gothic" pitchFamily="34" charset="-122"/>
-                          <a:cs typeface="Malgun Gothic" pitchFamily="34" charset="-120"/>
+                          <a:latin typeface="Noto Serif KR Black" pitchFamily="34" charset="0"/>
+                          <a:ea typeface="Noto Serif KR Black" pitchFamily="34" charset="-122"/>
+                          <a:cs typeface="Noto Serif KR Black" pitchFamily="34" charset="-120"/>
                         </a:rPr>
                         <a:t>6</a:t>
                       </a:r>
                       <a:endParaRPr lang="en-US" sz="1500" dirty="0">
-                        <a:latin typeface="Malgun Gothic" charset="0"/>
-                        <a:ea typeface="Malgun Gothic" charset="0"/>
-                        <a:cs typeface="Malgun Gothic" charset="0"/>
+                        <a:latin typeface="Noto Serif KR Black" charset="0"/>
+                        <a:ea typeface="Noto Serif KR Black" charset="0"/>
+                        <a:cs typeface="Noto Serif KR Black" charset="0"/>
                       </a:endParaRPr>
                     </a:p>
                   </a:txBody>
@@ -35593,16 +35593,16 @@
                           <a:solidFill>
                             <a:srgbClr val="222222"/>
                           </a:solidFill>
-                          <a:latin typeface="Malgun Gothic" pitchFamily="34" charset="0"/>
-                          <a:ea typeface="Malgun Gothic" pitchFamily="34" charset="-122"/>
-                          <a:cs typeface="Malgun Gothic" pitchFamily="34" charset="-120"/>
+                          <a:latin typeface="Noto Serif KR Black" pitchFamily="34" charset="0"/>
+                          <a:ea typeface="Noto Serif KR Black" pitchFamily="34" charset="-122"/>
+                          <a:cs typeface="Noto Serif KR Black" pitchFamily="34" charset="-120"/>
                         </a:rPr>
                         <a:t>연명의료에 대한 나의 생각이 어느 정도 정리되어 있다.</a:t>
                       </a:r>
                       <a:endParaRPr lang="en-US" sz="1500" dirty="0">
-                        <a:latin typeface="Malgun Gothic" charset="0"/>
-                        <a:ea typeface="Malgun Gothic" charset="0"/>
-                        <a:cs typeface="Malgun Gothic" charset="0"/>
+                        <a:latin typeface="Noto Serif KR Black" charset="0"/>
+                        <a:ea typeface="Noto Serif KR Black" charset="0"/>
+                        <a:cs typeface="Noto Serif KR Black" charset="0"/>
                       </a:endParaRPr>
                     </a:p>
                   </a:txBody>
@@ -35661,16 +35661,16 @@
                           <a:solidFill>
                             <a:srgbClr val="222222"/>
                           </a:solidFill>
-                          <a:latin typeface="Malgun Gothic" pitchFamily="34" charset="0"/>
-                          <a:ea typeface="Malgun Gothic" pitchFamily="34" charset="-122"/>
-                          <a:cs typeface="Malgun Gothic" pitchFamily="34" charset="-120"/>
+                          <a:latin typeface="Noto Serif KR Black" pitchFamily="34" charset="0"/>
+                          <a:ea typeface="Noto Serif KR Black" pitchFamily="34" charset="-122"/>
+                          <a:cs typeface="Noto Serif KR Black" pitchFamily="34" charset="-120"/>
                         </a:rPr>
                         <a:t>1  2  3  4  5</a:t>
                       </a:r>
                       <a:endParaRPr lang="en-US" sz="1500" dirty="0">
-                        <a:latin typeface="Malgun Gothic" charset="0"/>
-                        <a:ea typeface="Malgun Gothic" charset="0"/>
-                        <a:cs typeface="Malgun Gothic" charset="0"/>
+                        <a:latin typeface="Noto Serif KR Black" charset="0"/>
+                        <a:ea typeface="Noto Serif KR Black" charset="0"/>
+                        <a:cs typeface="Noto Serif KR Black" charset="0"/>
                       </a:endParaRPr>
                     </a:p>
                   </a:txBody>
@@ -35731,16 +35731,16 @@
                           <a:solidFill>
                             <a:srgbClr val="1F4E4A"/>
                           </a:solidFill>
-                          <a:latin typeface="Malgun Gothic" pitchFamily="34" charset="0"/>
-                          <a:ea typeface="Malgun Gothic" pitchFamily="34" charset="-122"/>
-                          <a:cs typeface="Malgun Gothic" pitchFamily="34" charset="-120"/>
+                          <a:latin typeface="Noto Serif KR Black" pitchFamily="34" charset="0"/>
+                          <a:ea typeface="Noto Serif KR Black" pitchFamily="34" charset="-122"/>
+                          <a:cs typeface="Noto Serif KR Black" pitchFamily="34" charset="-120"/>
                         </a:rPr>
                         <a:t>7</a:t>
                       </a:r>
                       <a:endParaRPr lang="en-US" sz="1500" dirty="0">
-                        <a:latin typeface="Malgun Gothic" charset="0"/>
-                        <a:ea typeface="Malgun Gothic" charset="0"/>
-                        <a:cs typeface="Malgun Gothic" charset="0"/>
+                        <a:latin typeface="Noto Serif KR Black" charset="0"/>
+                        <a:ea typeface="Noto Serif KR Black" charset="0"/>
+                        <a:cs typeface="Noto Serif KR Black" charset="0"/>
                       </a:endParaRPr>
                     </a:p>
                   </a:txBody>
@@ -35799,16 +35799,16 @@
                           <a:solidFill>
                             <a:srgbClr val="222222"/>
                           </a:solidFill>
-                          <a:latin typeface="Malgun Gothic" pitchFamily="34" charset="0"/>
-                          <a:ea typeface="Malgun Gothic" pitchFamily="34" charset="-122"/>
-                          <a:cs typeface="Malgun Gothic" pitchFamily="34" charset="-120"/>
+                          <a:latin typeface="Noto Serif KR Black" pitchFamily="34" charset="0"/>
+                          <a:ea typeface="Noto Serif KR Black" pitchFamily="34" charset="-122"/>
+                          <a:cs typeface="Noto Serif KR Black" pitchFamily="34" charset="-120"/>
                         </a:rPr>
                         <a:t>지금 죽음을 맞는다면 가장 후회될 일이 무엇인지 알고 있다.</a:t>
                       </a:r>
                       <a:endParaRPr lang="en-US" sz="1500" dirty="0">
-                        <a:latin typeface="Malgun Gothic" charset="0"/>
-                        <a:ea typeface="Malgun Gothic" charset="0"/>
-                        <a:cs typeface="Malgun Gothic" charset="0"/>
+                        <a:latin typeface="Noto Serif KR Black" charset="0"/>
+                        <a:ea typeface="Noto Serif KR Black" charset="0"/>
+                        <a:cs typeface="Noto Serif KR Black" charset="0"/>
                       </a:endParaRPr>
                     </a:p>
                   </a:txBody>
@@ -35867,16 +35867,16 @@
                           <a:solidFill>
                             <a:srgbClr val="222222"/>
                           </a:solidFill>
-                          <a:latin typeface="Malgun Gothic" pitchFamily="34" charset="0"/>
-                          <a:ea typeface="Malgun Gothic" pitchFamily="34" charset="-122"/>
-                          <a:cs typeface="Malgun Gothic" pitchFamily="34" charset="-120"/>
+                          <a:latin typeface="Noto Serif KR Black" pitchFamily="34" charset="0"/>
+                          <a:ea typeface="Noto Serif KR Black" pitchFamily="34" charset="-122"/>
+                          <a:cs typeface="Noto Serif KR Black" pitchFamily="34" charset="-120"/>
                         </a:rPr>
                         <a:t>1  2  3  4  5</a:t>
                       </a:r>
                       <a:endParaRPr lang="en-US" sz="1500" dirty="0">
-                        <a:latin typeface="Malgun Gothic" charset="0"/>
-                        <a:ea typeface="Malgun Gothic" charset="0"/>
-                        <a:cs typeface="Malgun Gothic" charset="0"/>
+                        <a:latin typeface="Noto Serif KR Black" charset="0"/>
+                        <a:ea typeface="Noto Serif KR Black" charset="0"/>
+                        <a:cs typeface="Noto Serif KR Black" charset="0"/>
                       </a:endParaRPr>
                     </a:p>
                   </a:txBody>
@@ -35937,16 +35937,16 @@
                           <a:solidFill>
                             <a:srgbClr val="1F4E4A"/>
                           </a:solidFill>
-                          <a:latin typeface="Malgun Gothic" pitchFamily="34" charset="0"/>
-                          <a:ea typeface="Malgun Gothic" pitchFamily="34" charset="-122"/>
-                          <a:cs typeface="Malgun Gothic" pitchFamily="34" charset="-120"/>
+                          <a:latin typeface="Noto Serif KR Black" pitchFamily="34" charset="0"/>
+                          <a:ea typeface="Noto Serif KR Black" pitchFamily="34" charset="-122"/>
+                          <a:cs typeface="Noto Serif KR Black" pitchFamily="34" charset="-120"/>
                         </a:rPr>
                         <a:t>8</a:t>
                       </a:r>
                       <a:endParaRPr lang="en-US" sz="1500" dirty="0">
-                        <a:latin typeface="Malgun Gothic" charset="0"/>
-                        <a:ea typeface="Malgun Gothic" charset="0"/>
-                        <a:cs typeface="Malgun Gothic" charset="0"/>
+                        <a:latin typeface="Noto Serif KR Black" charset="0"/>
+                        <a:ea typeface="Noto Serif KR Black" charset="0"/>
+                        <a:cs typeface="Noto Serif KR Black" charset="0"/>
                       </a:endParaRPr>
                     </a:p>
                   </a:txBody>
@@ -36005,16 +36005,16 @@
                           <a:solidFill>
                             <a:srgbClr val="222222"/>
                           </a:solidFill>
-                          <a:latin typeface="Malgun Gothic" pitchFamily="34" charset="0"/>
-                          <a:ea typeface="Malgun Gothic" pitchFamily="34" charset="-122"/>
-                          <a:cs typeface="Malgun Gothic" pitchFamily="34" charset="-120"/>
+                          <a:latin typeface="Noto Serif KR Black" pitchFamily="34" charset="0"/>
+                          <a:ea typeface="Noto Serif KR Black" pitchFamily="34" charset="-122"/>
+                          <a:cs typeface="Noto Serif KR Black" pitchFamily="34" charset="-120"/>
                         </a:rPr>
                         <a:t>감사하거나 미안한 사람에게 마음을 표현하고 있다.</a:t>
                       </a:r>
                       <a:endParaRPr lang="en-US" sz="1500" dirty="0">
-                        <a:latin typeface="Malgun Gothic" charset="0"/>
-                        <a:ea typeface="Malgun Gothic" charset="0"/>
-                        <a:cs typeface="Malgun Gothic" charset="0"/>
+                        <a:latin typeface="Noto Serif KR Black" charset="0"/>
+                        <a:ea typeface="Noto Serif KR Black" charset="0"/>
+                        <a:cs typeface="Noto Serif KR Black" charset="0"/>
                       </a:endParaRPr>
                     </a:p>
                   </a:txBody>
@@ -36073,16 +36073,16 @@
                           <a:solidFill>
                             <a:srgbClr val="222222"/>
                           </a:solidFill>
-                          <a:latin typeface="Malgun Gothic" pitchFamily="34" charset="0"/>
-                          <a:ea typeface="Malgun Gothic" pitchFamily="34" charset="-122"/>
-                          <a:cs typeface="Malgun Gothic" pitchFamily="34" charset="-120"/>
+                          <a:latin typeface="Noto Serif KR Black" pitchFamily="34" charset="0"/>
+                          <a:ea typeface="Noto Serif KR Black" pitchFamily="34" charset="-122"/>
+                          <a:cs typeface="Noto Serif KR Black" pitchFamily="34" charset="-120"/>
                         </a:rPr>
                         <a:t>1  2  3  4  5</a:t>
                       </a:r>
                       <a:endParaRPr lang="en-US" sz="1500" dirty="0">
-                        <a:latin typeface="Malgun Gothic" charset="0"/>
-                        <a:ea typeface="Malgun Gothic" charset="0"/>
-                        <a:cs typeface="Malgun Gothic" charset="0"/>
+                        <a:latin typeface="Noto Serif KR Black" charset="0"/>
+                        <a:ea typeface="Noto Serif KR Black" charset="0"/>
+                        <a:cs typeface="Noto Serif KR Black" charset="0"/>
                       </a:endParaRPr>
                     </a:p>
                   </a:txBody>
@@ -36143,16 +36143,16 @@
                           <a:solidFill>
                             <a:srgbClr val="1F4E4A"/>
                           </a:solidFill>
-                          <a:latin typeface="Malgun Gothic" pitchFamily="34" charset="0"/>
-                          <a:ea typeface="Malgun Gothic" pitchFamily="34" charset="-122"/>
-                          <a:cs typeface="Malgun Gothic" pitchFamily="34" charset="-120"/>
+                          <a:latin typeface="Noto Serif KR Black" pitchFamily="34" charset="0"/>
+                          <a:ea typeface="Noto Serif KR Black" pitchFamily="34" charset="-122"/>
+                          <a:cs typeface="Noto Serif KR Black" pitchFamily="34" charset="-120"/>
                         </a:rPr>
                         <a:t>9</a:t>
                       </a:r>
                       <a:endParaRPr lang="en-US" sz="1500" dirty="0">
-                        <a:latin typeface="Malgun Gothic" charset="0"/>
-                        <a:ea typeface="Malgun Gothic" charset="0"/>
-                        <a:cs typeface="Malgun Gothic" charset="0"/>
+                        <a:latin typeface="Noto Serif KR Black" charset="0"/>
+                        <a:ea typeface="Noto Serif KR Black" charset="0"/>
+                        <a:cs typeface="Noto Serif KR Black" charset="0"/>
                       </a:endParaRPr>
                     </a:p>
                   </a:txBody>
@@ -36211,16 +36211,16 @@
                           <a:solidFill>
                             <a:srgbClr val="222222"/>
                           </a:solidFill>
-                          <a:latin typeface="Malgun Gothic" pitchFamily="34" charset="0"/>
-                          <a:ea typeface="Malgun Gothic" pitchFamily="34" charset="-122"/>
-                          <a:cs typeface="Malgun Gothic" pitchFamily="34" charset="-120"/>
+                          <a:latin typeface="Noto Serif KR Black" pitchFamily="34" charset="0"/>
+                          <a:ea typeface="Noto Serif KR Black" pitchFamily="34" charset="-122"/>
+                          <a:cs typeface="Noto Serif KR Black" pitchFamily="34" charset="-120"/>
                         </a:rPr>
                         <a:t>죽은 뒤 무엇으로 기억되고 싶은지 생각해 본 적이 있다.</a:t>
                       </a:r>
                       <a:endParaRPr lang="en-US" sz="1500" dirty="0">
-                        <a:latin typeface="Malgun Gothic" charset="0"/>
-                        <a:ea typeface="Malgun Gothic" charset="0"/>
-                        <a:cs typeface="Malgun Gothic" charset="0"/>
+                        <a:latin typeface="Noto Serif KR Black" charset="0"/>
+                        <a:ea typeface="Noto Serif KR Black" charset="0"/>
+                        <a:cs typeface="Noto Serif KR Black" charset="0"/>
                       </a:endParaRPr>
                     </a:p>
                   </a:txBody>
@@ -36279,16 +36279,16 @@
                           <a:solidFill>
                             <a:srgbClr val="222222"/>
                           </a:solidFill>
-                          <a:latin typeface="Malgun Gothic" pitchFamily="34" charset="0"/>
-                          <a:ea typeface="Malgun Gothic" pitchFamily="34" charset="-122"/>
-                          <a:cs typeface="Malgun Gothic" pitchFamily="34" charset="-120"/>
+                          <a:latin typeface="Noto Serif KR Black" pitchFamily="34" charset="0"/>
+                          <a:ea typeface="Noto Serif KR Black" pitchFamily="34" charset="-122"/>
+                          <a:cs typeface="Noto Serif KR Black" pitchFamily="34" charset="-120"/>
                         </a:rPr>
                         <a:t>1  2  3  4  5</a:t>
                       </a:r>
                       <a:endParaRPr lang="en-US" sz="1500" dirty="0">
-                        <a:latin typeface="Malgun Gothic" charset="0"/>
-                        <a:ea typeface="Malgun Gothic" charset="0"/>
-                        <a:cs typeface="Malgun Gothic" charset="0"/>
+                        <a:latin typeface="Noto Serif KR Black" charset="0"/>
+                        <a:ea typeface="Noto Serif KR Black" charset="0"/>
+                        <a:cs typeface="Noto Serif KR Black" charset="0"/>
                       </a:endParaRPr>
                     </a:p>
                   </a:txBody>
@@ -36349,16 +36349,16 @@
                           <a:solidFill>
                             <a:srgbClr val="1F4E4A"/>
                           </a:solidFill>
-                          <a:latin typeface="Malgun Gothic" pitchFamily="34" charset="0"/>
-                          <a:ea typeface="Malgun Gothic" pitchFamily="34" charset="-122"/>
-                          <a:cs typeface="Malgun Gothic" pitchFamily="34" charset="-120"/>
+                          <a:latin typeface="Noto Serif KR Black" pitchFamily="34" charset="0"/>
+                          <a:ea typeface="Noto Serif KR Black" pitchFamily="34" charset="-122"/>
+                          <a:cs typeface="Noto Serif KR Black" pitchFamily="34" charset="-120"/>
                         </a:rPr>
                         <a:t>10</a:t>
                       </a:r>
                       <a:endParaRPr lang="en-US" sz="1500" dirty="0">
-                        <a:latin typeface="Malgun Gothic" charset="0"/>
-                        <a:ea typeface="Malgun Gothic" charset="0"/>
-                        <a:cs typeface="Malgun Gothic" charset="0"/>
+                        <a:latin typeface="Noto Serif KR Black" charset="0"/>
+                        <a:ea typeface="Noto Serif KR Black" charset="0"/>
+                        <a:cs typeface="Noto Serif KR Black" charset="0"/>
                       </a:endParaRPr>
                     </a:p>
                   </a:txBody>
@@ -36417,16 +36417,16 @@
                           <a:solidFill>
                             <a:srgbClr val="222222"/>
                           </a:solidFill>
-                          <a:latin typeface="Malgun Gothic" pitchFamily="34" charset="0"/>
-                          <a:ea typeface="Malgun Gothic" pitchFamily="34" charset="-122"/>
-                          <a:cs typeface="Malgun Gothic" pitchFamily="34" charset="-120"/>
+                          <a:latin typeface="Noto Serif KR Black" pitchFamily="34" charset="0"/>
+                          <a:ea typeface="Noto Serif KR Black" pitchFamily="34" charset="-122"/>
+                          <a:cs typeface="Noto Serif KR Black" pitchFamily="34" charset="-120"/>
                         </a:rPr>
                         <a:t>죽음을 생각하면 오히려 오늘을 더 잘 살고 싶어진다.</a:t>
                       </a:r>
                       <a:endParaRPr lang="en-US" sz="1500" dirty="0">
-                        <a:latin typeface="Malgun Gothic" charset="0"/>
-                        <a:ea typeface="Malgun Gothic" charset="0"/>
-                        <a:cs typeface="Malgun Gothic" charset="0"/>
+                        <a:latin typeface="Noto Serif KR Black" charset="0"/>
+                        <a:ea typeface="Noto Serif KR Black" charset="0"/>
+                        <a:cs typeface="Noto Serif KR Black" charset="0"/>
                       </a:endParaRPr>
                     </a:p>
                   </a:txBody>
@@ -36485,16 +36485,16 @@
                           <a:solidFill>
                             <a:srgbClr val="222222"/>
                           </a:solidFill>
-                          <a:latin typeface="Malgun Gothic" pitchFamily="34" charset="0"/>
-                          <a:ea typeface="Malgun Gothic" pitchFamily="34" charset="-122"/>
-                          <a:cs typeface="Malgun Gothic" pitchFamily="34" charset="-120"/>
+                          <a:latin typeface="Noto Serif KR Black" pitchFamily="34" charset="0"/>
+                          <a:ea typeface="Noto Serif KR Black" pitchFamily="34" charset="-122"/>
+                          <a:cs typeface="Noto Serif KR Black" pitchFamily="34" charset="-120"/>
                         </a:rPr>
                         <a:t>1  2  3  4  5</a:t>
                       </a:r>
                       <a:endParaRPr lang="en-US" sz="1500" dirty="0">
-                        <a:latin typeface="Malgun Gothic" charset="0"/>
-                        <a:ea typeface="Malgun Gothic" charset="0"/>
-                        <a:cs typeface="Malgun Gothic" charset="0"/>
+                        <a:latin typeface="Noto Serif KR Black" charset="0"/>
+                        <a:ea typeface="Noto Serif KR Black" charset="0"/>
+                        <a:cs typeface="Noto Serif KR Black" charset="0"/>
                       </a:endParaRPr>
                     </a:p>
                   </a:txBody>
@@ -38562,16 +38562,16 @@
                           <a:solidFill>
                             <a:srgbClr val="FFFFFF"/>
                           </a:solidFill>
-                          <a:latin typeface="Malgun Gothic" pitchFamily="34" charset="0"/>
-                          <a:ea typeface="Malgun Gothic" pitchFamily="34" charset="-122"/>
-                          <a:cs typeface="Malgun Gothic" pitchFamily="34" charset="-120"/>
+                          <a:latin typeface="Noto Serif KR Black" pitchFamily="34" charset="0"/>
+                          <a:ea typeface="Noto Serif KR Black" pitchFamily="34" charset="-122"/>
+                          <a:cs typeface="Noto Serif KR Black" pitchFamily="34" charset="-120"/>
                         </a:rPr>
                         <a:t>영역</a:t>
                       </a:r>
                       <a:endParaRPr lang="en-US" sz="1700" dirty="0">
-                        <a:latin typeface="Malgun Gothic" charset="0"/>
-                        <a:ea typeface="Malgun Gothic" charset="0"/>
-                        <a:cs typeface="Malgun Gothic" charset="0"/>
+                        <a:latin typeface="Noto Serif KR Black" charset="0"/>
+                        <a:ea typeface="Noto Serif KR Black" charset="0"/>
+                        <a:cs typeface="Noto Serif KR Black" charset="0"/>
                       </a:endParaRPr>
                     </a:p>
                   </a:txBody>
@@ -38630,16 +38630,16 @@
                           <a:solidFill>
                             <a:srgbClr val="FFFFFF"/>
                           </a:solidFill>
-                          <a:latin typeface="Malgun Gothic" pitchFamily="34" charset="0"/>
-                          <a:ea typeface="Malgun Gothic" pitchFamily="34" charset="-122"/>
-                          <a:cs typeface="Malgun Gothic" pitchFamily="34" charset="-120"/>
+                          <a:latin typeface="Noto Serif KR Black" pitchFamily="34" charset="0"/>
+                          <a:ea typeface="Noto Serif KR Black" pitchFamily="34" charset="-122"/>
+                          <a:cs typeface="Noto Serif KR Black" pitchFamily="34" charset="-120"/>
                         </a:rPr>
                         <a:t>질문</a:t>
                       </a:r>
                       <a:endParaRPr lang="en-US" sz="1700" dirty="0">
-                        <a:latin typeface="Malgun Gothic" charset="0"/>
-                        <a:ea typeface="Malgun Gothic" charset="0"/>
-                        <a:cs typeface="Malgun Gothic" charset="0"/>
+                        <a:latin typeface="Noto Serif KR Black" charset="0"/>
+                        <a:ea typeface="Noto Serif KR Black" charset="0"/>
+                        <a:cs typeface="Noto Serif KR Black" charset="0"/>
                       </a:endParaRPr>
                     </a:p>
                   </a:txBody>
@@ -38698,16 +38698,16 @@
                           <a:solidFill>
                             <a:srgbClr val="FFFFFF"/>
                           </a:solidFill>
-                          <a:latin typeface="Malgun Gothic" pitchFamily="34" charset="0"/>
-                          <a:ea typeface="Malgun Gothic" pitchFamily="34" charset="-122"/>
-                          <a:cs typeface="Malgun Gothic" pitchFamily="34" charset="-120"/>
+                          <a:latin typeface="Noto Serif KR Black" pitchFamily="34" charset="0"/>
+                          <a:ea typeface="Noto Serif KR Black" pitchFamily="34" charset="-122"/>
+                          <a:cs typeface="Noto Serif KR Black" pitchFamily="34" charset="-120"/>
                         </a:rPr>
                         <a:t>지금 준비할 한 가지</a:t>
                       </a:r>
                       <a:endParaRPr lang="en-US" sz="1700" dirty="0">
-                        <a:latin typeface="Malgun Gothic" charset="0"/>
-                        <a:ea typeface="Malgun Gothic" charset="0"/>
-                        <a:cs typeface="Malgun Gothic" charset="0"/>
+                        <a:latin typeface="Noto Serif KR Black" charset="0"/>
+                        <a:ea typeface="Noto Serif KR Black" charset="0"/>
+                        <a:cs typeface="Noto Serif KR Black" charset="0"/>
                       </a:endParaRPr>
                     </a:p>
                   </a:txBody>
@@ -38768,16 +38768,16 @@
                           <a:solidFill>
                             <a:srgbClr val="1F4E4A"/>
                           </a:solidFill>
-                          <a:latin typeface="Malgun Gothic" pitchFamily="34" charset="0"/>
-                          <a:ea typeface="Malgun Gothic" pitchFamily="34" charset="-122"/>
-                          <a:cs typeface="Malgun Gothic" pitchFamily="34" charset="-120"/>
+                          <a:latin typeface="Noto Serif KR Black" pitchFamily="34" charset="0"/>
+                          <a:ea typeface="Noto Serif KR Black" pitchFamily="34" charset="-122"/>
+                          <a:cs typeface="Noto Serif KR Black" pitchFamily="34" charset="-120"/>
                         </a:rPr>
                         <a:t>거주</a:t>
                       </a:r>
                       <a:endParaRPr lang="en-US" sz="1700" dirty="0">
-                        <a:latin typeface="Malgun Gothic" charset="0"/>
-                        <a:ea typeface="Malgun Gothic" charset="0"/>
-                        <a:cs typeface="Malgun Gothic" charset="0"/>
+                        <a:latin typeface="Noto Serif KR Black" charset="0"/>
+                        <a:ea typeface="Noto Serif KR Black" charset="0"/>
+                        <a:cs typeface="Noto Serif KR Black" charset="0"/>
                       </a:endParaRPr>
                     </a:p>
                   </a:txBody>
@@ -38836,16 +38836,16 @@
                           <a:solidFill>
                             <a:srgbClr val="222222"/>
                           </a:solidFill>
-                          <a:latin typeface="Malgun Gothic" pitchFamily="34" charset="0"/>
-                          <a:ea typeface="Malgun Gothic" pitchFamily="34" charset="-122"/>
-                          <a:cs typeface="Malgun Gothic" pitchFamily="34" charset="-120"/>
+                          <a:latin typeface="Noto Serif KR Black" pitchFamily="34" charset="0"/>
+                          <a:ea typeface="Noto Serif KR Black" pitchFamily="34" charset="-122"/>
+                          <a:cs typeface="Noto Serif KR Black" pitchFamily="34" charset="-120"/>
                         </a:rPr>
                         <a:t>어디에서, 누구와 살고 싶은가?</a:t>
                       </a:r>
                       <a:endParaRPr lang="en-US" sz="1700" dirty="0">
-                        <a:latin typeface="Malgun Gothic" charset="0"/>
-                        <a:ea typeface="Malgun Gothic" charset="0"/>
-                        <a:cs typeface="Malgun Gothic" charset="0"/>
+                        <a:latin typeface="Noto Serif KR Black" charset="0"/>
+                        <a:ea typeface="Noto Serif KR Black" charset="0"/>
+                        <a:cs typeface="Noto Serif KR Black" charset="0"/>
                       </a:endParaRPr>
                     </a:p>
                   </a:txBody>
@@ -38900,9 +38900,9 @@
                         <a:buNone/>
                       </a:pPr>
                       <a:endParaRPr lang="en-US" sz="1700" dirty="0">
-                        <a:latin typeface="Malgun Gothic" charset="0"/>
-                        <a:ea typeface="Malgun Gothic" charset="0"/>
-                        <a:cs typeface="Malgun Gothic" charset="0"/>
+                        <a:latin typeface="Noto Serif KR Black" charset="0"/>
+                        <a:ea typeface="Noto Serif KR Black" charset="0"/>
+                        <a:cs typeface="Noto Serif KR Black" charset="0"/>
                       </a:endParaRPr>
                     </a:p>
                   </a:txBody>
@@ -38963,16 +38963,16 @@
                           <a:solidFill>
                             <a:srgbClr val="1F4E4A"/>
                           </a:solidFill>
-                          <a:latin typeface="Malgun Gothic" pitchFamily="34" charset="0"/>
-                          <a:ea typeface="Malgun Gothic" pitchFamily="34" charset="-122"/>
-                          <a:cs typeface="Malgun Gothic" pitchFamily="34" charset="-120"/>
+                          <a:latin typeface="Noto Serif KR Black" pitchFamily="34" charset="0"/>
+                          <a:ea typeface="Noto Serif KR Black" pitchFamily="34" charset="-122"/>
+                          <a:cs typeface="Noto Serif KR Black" pitchFamily="34" charset="-120"/>
                         </a:rPr>
                         <a:t>관계</a:t>
                       </a:r>
                       <a:endParaRPr lang="en-US" sz="1700" dirty="0">
-                        <a:latin typeface="Malgun Gothic" charset="0"/>
-                        <a:ea typeface="Malgun Gothic" charset="0"/>
-                        <a:cs typeface="Malgun Gothic" charset="0"/>
+                        <a:latin typeface="Noto Serif KR Black" charset="0"/>
+                        <a:ea typeface="Noto Serif KR Black" charset="0"/>
+                        <a:cs typeface="Noto Serif KR Black" charset="0"/>
                       </a:endParaRPr>
                     </a:p>
                   </a:txBody>
@@ -39031,16 +39031,16 @@
                           <a:solidFill>
                             <a:srgbClr val="222222"/>
                           </a:solidFill>
-                          <a:latin typeface="Malgun Gothic" pitchFamily="34" charset="0"/>
-                          <a:ea typeface="Malgun Gothic" pitchFamily="34" charset="-122"/>
-                          <a:cs typeface="Malgun Gothic" pitchFamily="34" charset="-120"/>
+                          <a:latin typeface="Noto Serif KR Black" pitchFamily="34" charset="0"/>
+                          <a:ea typeface="Noto Serif KR Black" pitchFamily="34" charset="-122"/>
+                          <a:cs typeface="Noto Serif KR Black" pitchFamily="34" charset="-120"/>
                         </a:rPr>
                         <a:t>누구와 더 많은 시간을 보내고 싶은가?</a:t>
                       </a:r>
                       <a:endParaRPr lang="en-US" sz="1700" dirty="0">
-                        <a:latin typeface="Malgun Gothic" charset="0"/>
-                        <a:ea typeface="Malgun Gothic" charset="0"/>
-                        <a:cs typeface="Malgun Gothic" charset="0"/>
+                        <a:latin typeface="Noto Serif KR Black" charset="0"/>
+                        <a:ea typeface="Noto Serif KR Black" charset="0"/>
+                        <a:cs typeface="Noto Serif KR Black" charset="0"/>
                       </a:endParaRPr>
                     </a:p>
                   </a:txBody>
@@ -39095,9 +39095,9 @@
                         <a:buNone/>
                       </a:pPr>
                       <a:endParaRPr lang="en-US" sz="1700" dirty="0">
-                        <a:latin typeface="Malgun Gothic" charset="0"/>
-                        <a:ea typeface="Malgun Gothic" charset="0"/>
-                        <a:cs typeface="Malgun Gothic" charset="0"/>
+                        <a:latin typeface="Noto Serif KR Black" charset="0"/>
+                        <a:ea typeface="Noto Serif KR Black" charset="0"/>
+                        <a:cs typeface="Noto Serif KR Black" charset="0"/>
                       </a:endParaRPr>
                     </a:p>
                   </a:txBody>
@@ -39158,16 +39158,16 @@
                           <a:solidFill>
                             <a:srgbClr val="1F4E4A"/>
                           </a:solidFill>
-                          <a:latin typeface="Malgun Gothic" pitchFamily="34" charset="0"/>
-                          <a:ea typeface="Malgun Gothic" pitchFamily="34" charset="-122"/>
-                          <a:cs typeface="Malgun Gothic" pitchFamily="34" charset="-120"/>
+                          <a:latin typeface="Noto Serif KR Black" pitchFamily="34" charset="0"/>
+                          <a:ea typeface="Noto Serif KR Black" pitchFamily="34" charset="-122"/>
+                          <a:cs typeface="Noto Serif KR Black" pitchFamily="34" charset="-120"/>
                         </a:rPr>
                         <a:t>경제</a:t>
                       </a:r>
                       <a:endParaRPr lang="en-US" sz="1700" dirty="0">
-                        <a:latin typeface="Malgun Gothic" charset="0"/>
-                        <a:ea typeface="Malgun Gothic" charset="0"/>
-                        <a:cs typeface="Malgun Gothic" charset="0"/>
+                        <a:latin typeface="Noto Serif KR Black" charset="0"/>
+                        <a:ea typeface="Noto Serif KR Black" charset="0"/>
+                        <a:cs typeface="Noto Serif KR Black" charset="0"/>
                       </a:endParaRPr>
                     </a:p>
                   </a:txBody>
@@ -39226,16 +39226,16 @@
                           <a:solidFill>
                             <a:srgbClr val="222222"/>
                           </a:solidFill>
-                          <a:latin typeface="Malgun Gothic" pitchFamily="34" charset="0"/>
-                          <a:ea typeface="Malgun Gothic" pitchFamily="34" charset="-122"/>
-                          <a:cs typeface="Malgun Gothic" pitchFamily="34" charset="-120"/>
+                          <a:latin typeface="Noto Serif KR Black" pitchFamily="34" charset="0"/>
+                          <a:ea typeface="Noto Serif KR Black" pitchFamily="34" charset="-122"/>
+                          <a:cs typeface="Noto Serif KR Black" pitchFamily="34" charset="-120"/>
                         </a:rPr>
                         <a:t>의료·돌봄·생활비에 대해 무엇을 점검해야 하는가?</a:t>
                       </a:r>
                       <a:endParaRPr lang="en-US" sz="1700" dirty="0">
-                        <a:latin typeface="Malgun Gothic" charset="0"/>
-                        <a:ea typeface="Malgun Gothic" charset="0"/>
-                        <a:cs typeface="Malgun Gothic" charset="0"/>
+                        <a:latin typeface="Noto Serif KR Black" charset="0"/>
+                        <a:ea typeface="Noto Serif KR Black" charset="0"/>
+                        <a:cs typeface="Noto Serif KR Black" charset="0"/>
                       </a:endParaRPr>
                     </a:p>
                   </a:txBody>
@@ -39290,9 +39290,9 @@
                         <a:buNone/>
                       </a:pPr>
                       <a:endParaRPr lang="en-US" sz="1700" dirty="0">
-                        <a:latin typeface="Malgun Gothic" charset="0"/>
-                        <a:ea typeface="Malgun Gothic" charset="0"/>
-                        <a:cs typeface="Malgun Gothic" charset="0"/>
+                        <a:latin typeface="Noto Serif KR Black" charset="0"/>
+                        <a:ea typeface="Noto Serif KR Black" charset="0"/>
+                        <a:cs typeface="Noto Serif KR Black" charset="0"/>
                       </a:endParaRPr>
                     </a:p>
                   </a:txBody>
@@ -39353,16 +39353,16 @@
                           <a:solidFill>
                             <a:srgbClr val="1F4E4A"/>
                           </a:solidFill>
-                          <a:latin typeface="Malgun Gothic" pitchFamily="34" charset="0"/>
-                          <a:ea typeface="Malgun Gothic" pitchFamily="34" charset="-122"/>
-                          <a:cs typeface="Malgun Gothic" pitchFamily="34" charset="-120"/>
+                          <a:latin typeface="Noto Serif KR Black" pitchFamily="34" charset="0"/>
+                          <a:ea typeface="Noto Serif KR Black" pitchFamily="34" charset="-122"/>
+                          <a:cs typeface="Noto Serif KR Black" pitchFamily="34" charset="-120"/>
                         </a:rPr>
                         <a:t>활동</a:t>
                       </a:r>
                       <a:endParaRPr lang="en-US" sz="1700" dirty="0">
-                        <a:latin typeface="Malgun Gothic" charset="0"/>
-                        <a:ea typeface="Malgun Gothic" charset="0"/>
-                        <a:cs typeface="Malgun Gothic" charset="0"/>
+                        <a:latin typeface="Noto Serif KR Black" charset="0"/>
+                        <a:ea typeface="Noto Serif KR Black" charset="0"/>
+                        <a:cs typeface="Noto Serif KR Black" charset="0"/>
                       </a:endParaRPr>
                     </a:p>
                   </a:txBody>
@@ -39421,16 +39421,16 @@
                           <a:solidFill>
                             <a:srgbClr val="222222"/>
                           </a:solidFill>
-                          <a:latin typeface="Malgun Gothic" pitchFamily="34" charset="0"/>
-                          <a:ea typeface="Malgun Gothic" pitchFamily="34" charset="-122"/>
-                          <a:cs typeface="Malgun Gothic" pitchFamily="34" charset="-120"/>
+                          <a:latin typeface="Noto Serif KR Black" pitchFamily="34" charset="0"/>
+                          <a:ea typeface="Noto Serif KR Black" pitchFamily="34" charset="-122"/>
+                          <a:cs typeface="Noto Serif KR Black" pitchFamily="34" charset="-120"/>
                         </a:rPr>
                         <a:t>삶의 활력을 위해 계속하고 싶은 활동은?</a:t>
                       </a:r>
                       <a:endParaRPr lang="en-US" sz="1700" dirty="0">
-                        <a:latin typeface="Malgun Gothic" charset="0"/>
-                        <a:ea typeface="Malgun Gothic" charset="0"/>
-                        <a:cs typeface="Malgun Gothic" charset="0"/>
+                        <a:latin typeface="Noto Serif KR Black" charset="0"/>
+                        <a:ea typeface="Noto Serif KR Black" charset="0"/>
+                        <a:cs typeface="Noto Serif KR Black" charset="0"/>
                       </a:endParaRPr>
                     </a:p>
                   </a:txBody>
@@ -39485,9 +39485,9 @@
                         <a:buNone/>
                       </a:pPr>
                       <a:endParaRPr lang="en-US" sz="1700" dirty="0">
-                        <a:latin typeface="Malgun Gothic" charset="0"/>
-                        <a:ea typeface="Malgun Gothic" charset="0"/>
-                        <a:cs typeface="Malgun Gothic" charset="0"/>
+                        <a:latin typeface="Noto Serif KR Black" charset="0"/>
+                        <a:ea typeface="Noto Serif KR Black" charset="0"/>
+                        <a:cs typeface="Noto Serif KR Black" charset="0"/>
                       </a:endParaRPr>
                     </a:p>
                   </a:txBody>
@@ -39548,16 +39548,16 @@
                           <a:solidFill>
                             <a:srgbClr val="1F4E4A"/>
                           </a:solidFill>
-                          <a:latin typeface="Malgun Gothic" pitchFamily="34" charset="0"/>
-                          <a:ea typeface="Malgun Gothic" pitchFamily="34" charset="-122"/>
-                          <a:cs typeface="Malgun Gothic" pitchFamily="34" charset="-120"/>
+                          <a:latin typeface="Noto Serif KR Black" pitchFamily="34" charset="0"/>
+                          <a:ea typeface="Noto Serif KR Black" pitchFamily="34" charset="-122"/>
+                          <a:cs typeface="Noto Serif KR Black" pitchFamily="34" charset="-120"/>
                         </a:rPr>
                         <a:t>의료·돌봄</a:t>
                       </a:r>
                       <a:endParaRPr lang="en-US" sz="1700" dirty="0">
-                        <a:latin typeface="Malgun Gothic" charset="0"/>
-                        <a:ea typeface="Malgun Gothic" charset="0"/>
-                        <a:cs typeface="Malgun Gothic" charset="0"/>
+                        <a:latin typeface="Noto Serif KR Black" charset="0"/>
+                        <a:ea typeface="Noto Serif KR Black" charset="0"/>
+                        <a:cs typeface="Noto Serif KR Black" charset="0"/>
                       </a:endParaRPr>
                     </a:p>
                   </a:txBody>
@@ -39616,16 +39616,16 @@
                           <a:solidFill>
                             <a:srgbClr val="222222"/>
                           </a:solidFill>
-                          <a:latin typeface="Malgun Gothic" pitchFamily="34" charset="0"/>
-                          <a:ea typeface="Malgun Gothic" pitchFamily="34" charset="-122"/>
-                          <a:cs typeface="Malgun Gothic" pitchFamily="34" charset="-120"/>
+                          <a:latin typeface="Noto Serif KR Black" pitchFamily="34" charset="0"/>
+                          <a:ea typeface="Noto Serif KR Black" pitchFamily="34" charset="-122"/>
+                          <a:cs typeface="Noto Serif KR Black" pitchFamily="34" charset="-120"/>
                         </a:rPr>
                         <a:t>어떤 의료와 돌봄을 원하며 누구와 상의할 것인가?</a:t>
                       </a:r>
                       <a:endParaRPr lang="en-US" sz="1700" dirty="0">
-                        <a:latin typeface="Malgun Gothic" charset="0"/>
-                        <a:ea typeface="Malgun Gothic" charset="0"/>
-                        <a:cs typeface="Malgun Gothic" charset="0"/>
+                        <a:latin typeface="Noto Serif KR Black" charset="0"/>
+                        <a:ea typeface="Noto Serif KR Black" charset="0"/>
+                        <a:cs typeface="Noto Serif KR Black" charset="0"/>
                       </a:endParaRPr>
                     </a:p>
                   </a:txBody>
@@ -39680,9 +39680,9 @@
                         <a:buNone/>
                       </a:pPr>
                       <a:endParaRPr lang="en-US" sz="1700" dirty="0">
-                        <a:latin typeface="Malgun Gothic" charset="0"/>
-                        <a:ea typeface="Malgun Gothic" charset="0"/>
-                        <a:cs typeface="Malgun Gothic" charset="0"/>
+                        <a:latin typeface="Noto Serif KR Black" charset="0"/>
+                        <a:ea typeface="Noto Serif KR Black" charset="0"/>
+                        <a:cs typeface="Noto Serif KR Black" charset="0"/>
                       </a:endParaRPr>
                     </a:p>
                   </a:txBody>
@@ -39743,16 +39743,16 @@
                           <a:solidFill>
                             <a:srgbClr val="1F4E4A"/>
                           </a:solidFill>
-                          <a:latin typeface="Malgun Gothic" pitchFamily="34" charset="0"/>
-                          <a:ea typeface="Malgun Gothic" pitchFamily="34" charset="-122"/>
-                          <a:cs typeface="Malgun Gothic" pitchFamily="34" charset="-120"/>
+                          <a:latin typeface="Noto Serif KR Black" pitchFamily="34" charset="0"/>
+                          <a:ea typeface="Noto Serif KR Black" pitchFamily="34" charset="-122"/>
+                          <a:cs typeface="Noto Serif KR Black" pitchFamily="34" charset="-120"/>
                         </a:rPr>
                         <a:t>레거시</a:t>
                       </a:r>
                       <a:endParaRPr lang="en-US" sz="1700" dirty="0">
-                        <a:latin typeface="Malgun Gothic" charset="0"/>
-                        <a:ea typeface="Malgun Gothic" charset="0"/>
-                        <a:cs typeface="Malgun Gothic" charset="0"/>
+                        <a:latin typeface="Noto Serif KR Black" charset="0"/>
+                        <a:ea typeface="Noto Serif KR Black" charset="0"/>
+                        <a:cs typeface="Noto Serif KR Black" charset="0"/>
                       </a:endParaRPr>
                     </a:p>
                   </a:txBody>
@@ -39811,16 +39811,16 @@
                           <a:solidFill>
                             <a:srgbClr val="222222"/>
                           </a:solidFill>
-                          <a:latin typeface="Malgun Gothic" pitchFamily="34" charset="0"/>
-                          <a:ea typeface="Malgun Gothic" pitchFamily="34" charset="-122"/>
-                          <a:cs typeface="Malgun Gothic" pitchFamily="34" charset="-120"/>
+                          <a:latin typeface="Noto Serif KR Black" pitchFamily="34" charset="0"/>
+                          <a:ea typeface="Noto Serif KR Black" pitchFamily="34" charset="-122"/>
+                          <a:cs typeface="Noto Serif KR Black" pitchFamily="34" charset="-120"/>
                         </a:rPr>
                         <a:t>무엇을 남기고 어떻게 기억되고 싶은가?</a:t>
                       </a:r>
                       <a:endParaRPr lang="en-US" sz="1700" dirty="0">
-                        <a:latin typeface="Malgun Gothic" charset="0"/>
-                        <a:ea typeface="Malgun Gothic" charset="0"/>
-                        <a:cs typeface="Malgun Gothic" charset="0"/>
+                        <a:latin typeface="Noto Serif KR Black" charset="0"/>
+                        <a:ea typeface="Noto Serif KR Black" charset="0"/>
+                        <a:cs typeface="Noto Serif KR Black" charset="0"/>
                       </a:endParaRPr>
                     </a:p>
                   </a:txBody>
@@ -39875,9 +39875,9 @@
                         <a:buNone/>
                       </a:pPr>
                       <a:endParaRPr lang="en-US" sz="1700" dirty="0">
-                        <a:latin typeface="Malgun Gothic" charset="0"/>
-                        <a:ea typeface="Malgun Gothic" charset="0"/>
-                        <a:cs typeface="Malgun Gothic" charset="0"/>
+                        <a:latin typeface="Noto Serif KR Black" charset="0"/>
+                        <a:ea typeface="Noto Serif KR Black" charset="0"/>
+                        <a:cs typeface="Noto Serif KR Black" charset="0"/>
                       </a:endParaRPr>
                     </a:p>
                   </a:txBody>
@@ -54334,7 +54334,7 @@
     </a:clrScheme>
     <a:fontScheme name="WLC Teal">
       <a:majorFont>
-        <a:latin typeface="Malgun Gothic"/>
+        <a:latin typeface="Noto Serif KR Black"/>
         <a:ea typeface=""/>
         <a:cs typeface=""/>
         <a:font script="Jpan" typeface="游ゴシック Light"/>
@@ -54386,7 +54386,7 @@
         <a:font script="Tfng" typeface="Ebrima"/>
       </a:majorFont>
       <a:minorFont>
-        <a:latin typeface="Malgun Gothic"/>
+        <a:latin typeface="Noto Serif KR Black"/>
         <a:ea typeface=""/>
         <a:cs typeface=""/>
         <a:font script="Jpan" typeface="游ゴシック"/>

</xml_diff>

<commit_message>
Add lecture 3 PPT and unify list font sizes
Lecture 3 (웰빙·웰다잉·엔딩의 통합철학과 삶의 설계): 56 slides, 180 minutes,
life graph, backcasting role-play, remaining-life one-page plan, legacy
statement, quizzes, and lecture 4 preview. Numbered lists now use one
font size per slide; lectures 1-2 rebuilt.

Co-Authored-By: Claude Opus 5.5 <noreply@anthropic.com>
Claude-Session: https://claude.ai/code/session_011L3sm83vPfAuzHdbV1bgYe
</commit_message>
<xml_diff>
--- a/ppt/out/WLC2급_제01강_죽음을이해하는통찰.pptx
+++ b/ppt/out/WLC2급_제01강_죽음을이해하는통찰.pptx
@@ -164,7 +164,7 @@
   <p:extLst>
     <p:ext uri="{521415D9-36F7-43E2-AB2F-B90AF26B5E84}">
       <p14:sectionLst xmlns:p14="http://schemas.microsoft.com/office/powerpoint/2010/main">
-        <p14:section name="열기" id="{bf24678e-e1b9-ed97-f856-f808f01a28af}">
+        <p14:section name="열기" id="{81ec9cba-e361-b03c-9128-13a8341d9896}">
           <p14:sldIdLst>
             <p14:sldId id="256"/>
             <p14:sldId id="257"/>
@@ -176,7 +176,7 @@
             <p14:sldId id="263"/>
           </p14:sldIdLst>
         </p14:section>
-        <p14:section name="1교시 죽음을 여러 눈으로" id="{82d36adc-cf77-a41e-64e9-5cff614fb769}">
+        <p14:section name="1교시 죽음을 여러 눈으로" id="{5ef8c00a-30ba-820f-e3a4-1a42ee1ff2e8}">
           <p14:sldIdLst>
             <p14:sldId id="264"/>
             <p14:sldId id="265"/>
@@ -191,7 +191,7 @@
             <p14:sldId id="274"/>
           </p14:sldIdLst>
         </p14:section>
-        <p14:section name="2교시 두려움과 경계" id="{ccc56e31-d532-7b1d-aed9-415cf2be3204}">
+        <p14:section name="2교시 두려움과 경계" id="{4ab79764-2045-de37-0a23-e2a7127856d6}">
           <p14:sldIdLst>
             <p14:sldId id="275"/>
             <p14:sldId id="276"/>
@@ -211,7 +211,7 @@
             <p14:sldId id="290"/>
           </p14:sldIdLst>
         </p14:section>
-        <p14:section name="3교시 통찰을 삶으로" id="{da2facea-60be-09ab-6d53-acf6ce2967d7}">
+        <p14:section name="3교시 통찰을 삶으로" id="{babe4a8f-6692-b239-4c31-047a56d423b3}">
           <p14:sldIdLst>
             <p14:sldId id="291"/>
             <p14:sldId id="292"/>
@@ -232,7 +232,7 @@
             <p14:sldId id="307"/>
           </p14:sldIdLst>
         </p14:section>
-        <p14:section name="정리와 예고" id="{d8d13f19-3cf7-5825-b895-462a05d5a79e}">
+        <p14:section name="정리와 예고" id="{e5be9373-0fe4-debd-5112-ad42f5aff98e}">
           <p14:sldIdLst>
             <p14:sldId id="308"/>
             <p14:sldId id="309"/>
@@ -51801,7 +51801,7 @@
               <a:buNone/>
             </a:pPr>
             <a:r>
-              <a:rPr lang="en-US" sz="2200" b="1" dirty="0">
+              <a:rPr lang="en-US" sz="2100" b="1" dirty="0">
                 <a:solidFill>
                   <a:srgbClr val="1F4E4A"/>
                 </a:solidFill>
@@ -51812,14 +51812,14 @@
               <a:buNone/>
             </a:pPr>
             <a:r>
-              <a:rPr lang="en-US" sz="2200" dirty="0">
+              <a:rPr lang="en-US" sz="2100" dirty="0">
                 <a:solidFill>
                   <a:srgbClr val="222222"/>
                 </a:solidFill>
               </a:rPr>
               <a:t>죽음을 6가지 관점에서 설명한다</a:t>
             </a:r>
-            <a:endParaRPr lang="en-US" sz="2200" dirty="0"/>
+            <a:endParaRPr lang="en-US" sz="2100" dirty="0"/>
           </a:p>
         </p:txBody>
       </p:sp>
@@ -52017,7 +52017,7 @@
               <a:buNone/>
             </a:pPr>
             <a:r>
-              <a:rPr lang="en-US" sz="2200" b="1" dirty="0">
+              <a:rPr lang="en-US" sz="2100" b="1" dirty="0">
                 <a:solidFill>
                   <a:srgbClr val="1F4E4A"/>
                 </a:solidFill>
@@ -52028,14 +52028,14 @@
               <a:buNone/>
             </a:pPr>
             <a:r>
-              <a:rPr lang="en-US" sz="2200" dirty="0">
+              <a:rPr lang="en-US" sz="2100" dirty="0">
                 <a:solidFill>
                   <a:srgbClr val="222222"/>
                 </a:solidFill>
               </a:rPr>
               <a:t>동서양 죽음관을 일반화하지 않고 코칭 언어를 고른다</a:t>
             </a:r>
-            <a:endParaRPr lang="en-US" sz="2200" dirty="0"/>
+            <a:endParaRPr lang="en-US" sz="2100" dirty="0"/>
           </a:p>
         </p:txBody>
       </p:sp>
@@ -52125,7 +52125,7 @@
               <a:buNone/>
             </a:pPr>
             <a:r>
-              <a:rPr lang="en-US" sz="2200" b="1" dirty="0">
+              <a:rPr lang="en-US" sz="2100" b="1" dirty="0">
                 <a:solidFill>
                   <a:srgbClr val="1F4E4A"/>
                 </a:solidFill>
@@ -52136,14 +52136,14 @@
               <a:buNone/>
             </a:pPr>
             <a:r>
-              <a:rPr lang="en-US" sz="2200" dirty="0">
+              <a:rPr lang="en-US" sz="2100" dirty="0">
                 <a:solidFill>
                   <a:srgbClr val="222222"/>
                 </a:solidFill>
               </a:rPr>
               <a:t>불안 유형을 구분하고 가치·행동으로 잇는 질문을 만든다</a:t>
             </a:r>
-            <a:endParaRPr lang="en-US" sz="2200" dirty="0"/>
+            <a:endParaRPr lang="en-US" sz="2100" dirty="0"/>
           </a:p>
         </p:txBody>
       </p:sp>
@@ -52233,7 +52233,7 @@
               <a:buNone/>
             </a:pPr>
             <a:r>
-              <a:rPr lang="en-US" sz="2200" b="1" dirty="0">
+              <a:rPr lang="en-US" sz="2100" b="1" dirty="0">
                 <a:solidFill>
                   <a:srgbClr val="1F4E4A"/>
                 </a:solidFill>
@@ -52244,14 +52244,14 @@
               <a:buNone/>
             </a:pPr>
             <a:r>
-              <a:rPr lang="en-US" sz="2200" dirty="0">
+              <a:rPr lang="en-US" sz="2100" dirty="0">
                 <a:solidFill>
                   <a:srgbClr val="222222"/>
                 </a:solidFill>
               </a:rPr>
               <a:t>대상에 맞는 접근을 선택한다</a:t>
             </a:r>
-            <a:endParaRPr lang="en-US" sz="2200" dirty="0"/>
+            <a:endParaRPr lang="en-US" sz="2100" dirty="0"/>
           </a:p>
         </p:txBody>
       </p:sp>
@@ -52341,7 +52341,7 @@
               <a:buNone/>
             </a:pPr>
             <a:r>
-              <a:rPr lang="en-US" sz="2200" b="1" dirty="0">
+              <a:rPr lang="en-US" sz="2100" b="1" dirty="0">
                 <a:solidFill>
                   <a:srgbClr val="1F4E4A"/>
                 </a:solidFill>
@@ -52352,14 +52352,14 @@
               <a:buNone/>
             </a:pPr>
             <a:r>
-              <a:rPr lang="en-US" sz="2200" dirty="0">
+              <a:rPr lang="en-US" sz="2100" dirty="0">
                 <a:solidFill>
                   <a:srgbClr val="222222"/>
                 </a:solidFill>
               </a:rPr>
               <a:t>나의 죽음 태도와 WLC로서의 준비를 성찰한다</a:t>
             </a:r>
-            <a:endParaRPr lang="en-US" sz="2200" dirty="0"/>
+            <a:endParaRPr lang="en-US" sz="2100" dirty="0"/>
           </a:p>
         </p:txBody>
       </p:sp>
@@ -52449,7 +52449,7 @@
               <a:buNone/>
             </a:pPr>
             <a:r>
-              <a:rPr lang="en-US" sz="2200" b="1" dirty="0">
+              <a:rPr lang="en-US" sz="2100" b="1" dirty="0">
                 <a:solidFill>
                   <a:srgbClr val="1F4E4A"/>
                 </a:solidFill>
@@ -52460,14 +52460,14 @@
               <a:buNone/>
             </a:pPr>
             <a:r>
-              <a:rPr lang="en-US" sz="2200" dirty="0">
+              <a:rPr lang="en-US" sz="2100" dirty="0">
                 <a:solidFill>
                   <a:srgbClr val="222222"/>
                 </a:solidFill>
               </a:rPr>
               <a:t>의료·법률·장례·애도에서 전문가 영역을 구분한다</a:t>
             </a:r>
-            <a:endParaRPr lang="en-US" sz="2200" dirty="0"/>
+            <a:endParaRPr lang="en-US" sz="2100" dirty="0"/>
           </a:p>
         </p:txBody>
       </p:sp>
@@ -52557,7 +52557,7 @@
               <a:buNone/>
             </a:pPr>
             <a:r>
-              <a:rPr lang="en-US" sz="2200" b="1" dirty="0">
+              <a:rPr lang="en-US" sz="2100" b="1" dirty="0">
                 <a:solidFill>
                   <a:srgbClr val="1F4E4A"/>
                 </a:solidFill>
@@ -52568,14 +52568,14 @@
               <a:buNone/>
             </a:pPr>
             <a:r>
-              <a:rPr lang="en-US" sz="2200" dirty="0">
+              <a:rPr lang="en-US" sz="2100" dirty="0">
                 <a:solidFill>
                   <a:srgbClr val="222222"/>
                 </a:solidFill>
               </a:rPr>
               <a:t>웰빙–웰다잉–엔딩–레거시로 삶의 설계를 잇는다</a:t>
             </a:r>
-            <a:endParaRPr lang="en-US" sz="2200" dirty="0"/>
+            <a:endParaRPr lang="en-US" sz="2100" dirty="0"/>
           </a:p>
         </p:txBody>
       </p:sp>

</xml_diff>

<commit_message>
Add lecture 16 PPT (WLC 전문직 윤리·자격검정과 지속성장, course wrap-up); rebuild 1-11 with wrap-safe cover
Co-Authored-By: Claude Opus 5.5 <noreply@anthropic.com>
Claude-Session: https://claude.ai/code/session_011L3sm83vPfAuzHdbV1bgYe
</commit_message>
<xml_diff>
--- a/ppt/out/WLC2급_제01강_죽음을이해하는통찰.pptx
+++ b/ppt/out/WLC2급_제01강_죽음을이해하는통찰.pptx
@@ -164,7 +164,7 @@
   <p:extLst>
     <p:ext uri="{521415D9-36F7-43E2-AB2F-B90AF26B5E84}">
       <p14:sectionLst xmlns:p14="http://schemas.microsoft.com/office/powerpoint/2010/main">
-        <p14:section name="열기" id="{81ec9cba-e361-b03c-9128-13a8341d9896}">
+        <p14:section name="열기" id="{02904b9c-2a8f-b46d-8d17-4fc5dc1e5871}">
           <p14:sldIdLst>
             <p14:sldId id="256"/>
             <p14:sldId id="257"/>
@@ -176,7 +176,7 @@
             <p14:sldId id="263"/>
           </p14:sldIdLst>
         </p14:section>
-        <p14:section name="1교시 죽음을 여러 눈으로" id="{5ef8c00a-30ba-820f-e3a4-1a42ee1ff2e8}">
+        <p14:section name="1교시 죽음을 여러 눈으로" id="{c730b4c7-a476-6f58-2518-1a74c8504a75}">
           <p14:sldIdLst>
             <p14:sldId id="264"/>
             <p14:sldId id="265"/>
@@ -191,7 +191,7 @@
             <p14:sldId id="274"/>
           </p14:sldIdLst>
         </p14:section>
-        <p14:section name="2교시 두려움과 경계" id="{4ab79764-2045-de37-0a23-e2a7127856d6}">
+        <p14:section name="2교시 두려움과 경계" id="{33a85039-4819-95b3-a268-49aa07a10145}">
           <p14:sldIdLst>
             <p14:sldId id="275"/>
             <p14:sldId id="276"/>
@@ -211,7 +211,7 @@
             <p14:sldId id="290"/>
           </p14:sldIdLst>
         </p14:section>
-        <p14:section name="3교시 통찰을 삶으로" id="{babe4a8f-6692-b239-4c31-047a56d423b3}">
+        <p14:section name="3교시 통찰을 삶으로" id="{f96186bd-a170-7092-c047-d48e0e619d5b}">
           <p14:sldIdLst>
             <p14:sldId id="291"/>
             <p14:sldId id="292"/>
@@ -232,7 +232,7 @@
             <p14:sldId id="307"/>
           </p14:sldIdLst>
         </p14:section>
-        <p14:section name="정리와 예고" id="{e5be9373-0fe4-debd-5112-ad42f5aff98e}">
+        <p14:section name="정리와 예고" id="{3204447f-09c6-d0ad-d17a-560ea3377d20}">
           <p14:sldIdLst>
             <p14:sldId id="308"/>
             <p14:sldId id="309"/>
@@ -6966,7 +6966,7 @@
         <p:spPr>
           <a:xfrm>
             <a:off x="548640" y="2560320"/>
-            <a:ext cx="9144000" cy="1097280"/>
+            <a:ext cx="10607040" cy="1097280"/>
           </a:xfrm>
           <a:prstGeom prst="rect">
             <a:avLst/>
@@ -54292,47 +54292,47 @@
 </file>
 
 <file path=ppt/theme/theme1.xml><?xml version="1.0" encoding="utf-8"?>
-<a:theme xmlns:a="http://schemas.openxmlformats.org/drawingml/2006/main" name="WLC Teal">
+<a:theme xmlns:a="http://schemas.openxmlformats.org/drawingml/2006/main" name="Office Theme">
   <a:themeElements>
-    <a:clrScheme name="WLC Teal">
+    <a:clrScheme name="Office">
       <a:dk1>
-        <a:srgbClr val="222222"/>
+        <a:sysClr val="windowText" lastClr="000000"/>
       </a:dk1>
       <a:lt1>
-        <a:srgbClr val="FFFFFF"/>
+        <a:sysClr val="window" lastClr="FFFFFF"/>
       </a:lt1>
       <a:dk2>
-        <a:srgbClr val="1F4E4A"/>
+        <a:srgbClr val="44546A"/>
       </a:dk2>
       <a:lt2>
-        <a:srgbClr val="EAF3F0"/>
+        <a:srgbClr val="E7E6E6"/>
       </a:lt2>
       <a:accent1>
-        <a:srgbClr val="2E7D6B"/>
+        <a:srgbClr val="4472C4"/>
       </a:accent1>
       <a:accent2>
-        <a:srgbClr val="D98E04"/>
+        <a:srgbClr val="ED7D31"/>
       </a:accent2>
       <a:accent3>
-        <a:srgbClr val="3A6EA5"/>
+        <a:srgbClr val="A5A5A5"/>
       </a:accent3>
       <a:accent4>
-        <a:srgbClr val="B5452F"/>
+        <a:srgbClr val="FFC000"/>
       </a:accent4>
       <a:accent5>
-        <a:srgbClr val="8FB9A8"/>
+        <a:srgbClr val="5B9BD5"/>
       </a:accent5>
       <a:accent6>
-        <a:srgbClr val="6B6B6B"/>
+        <a:srgbClr val="70AD47"/>
       </a:accent6>
       <a:hlink>
-        <a:srgbClr val="3A6EA5"/>
+        <a:srgbClr val="0563C1"/>
       </a:hlink>
       <a:folHlink>
-        <a:srgbClr val="1F4E4A"/>
+        <a:srgbClr val="954F72"/>
       </a:folHlink>
     </a:clrScheme>
-    <a:fontScheme name="WLC Teal">
+    <a:fontScheme name="Office">
       <a:majorFont>
         <a:latin typeface="Noto Serif KR Black"/>
         <a:ea typeface=""/>

</xml_diff>

<commit_message>
Rebuild lectures 1-11 with wrap-safe cover title
Co-Authored-By: Claude Opus 5.5 <noreply@anthropic.com>
Claude-Session: https://claude.ai/code/session_011L3sm83vPfAuzHdbV1bgYe
</commit_message>
<xml_diff>
--- a/ppt/out/WLC2급_제01강_죽음을이해하는통찰.pptx
+++ b/ppt/out/WLC2급_제01강_죽음을이해하는통찰.pptx
@@ -164,7 +164,7 @@
   <p:extLst>
     <p:ext uri="{521415D9-36F7-43E2-AB2F-B90AF26B5E84}">
       <p14:sectionLst xmlns:p14="http://schemas.microsoft.com/office/powerpoint/2010/main">
-        <p14:section name="열기" id="{02904b9c-2a8f-b46d-8d17-4fc5dc1e5871}">
+        <p14:section name="열기" id="{7b2d9bbe-a3b6-aa4a-39bc-d9c38ed5d3ec}">
           <p14:sldIdLst>
             <p14:sldId id="256"/>
             <p14:sldId id="257"/>
@@ -176,7 +176,7 @@
             <p14:sldId id="263"/>
           </p14:sldIdLst>
         </p14:section>
-        <p14:section name="1교시 죽음을 여러 눈으로" id="{c730b4c7-a476-6f58-2518-1a74c8504a75}">
+        <p14:section name="1교시 죽음을 여러 눈으로" id="{3eaf7147-c9cc-b0b0-cdcf-e90840a46f1f}">
           <p14:sldIdLst>
             <p14:sldId id="264"/>
             <p14:sldId id="265"/>
@@ -191,7 +191,7 @@
             <p14:sldId id="274"/>
           </p14:sldIdLst>
         </p14:section>
-        <p14:section name="2교시 두려움과 경계" id="{33a85039-4819-95b3-a268-49aa07a10145}">
+        <p14:section name="2교시 두려움과 경계" id="{ce2f117a-59f1-3816-202b-a8ee1f69be26}">
           <p14:sldIdLst>
             <p14:sldId id="275"/>
             <p14:sldId id="276"/>
@@ -211,7 +211,7 @@
             <p14:sldId id="290"/>
           </p14:sldIdLst>
         </p14:section>
-        <p14:section name="3교시 통찰을 삶으로" id="{f96186bd-a170-7092-c047-d48e0e619d5b}">
+        <p14:section name="3교시 통찰을 삶으로" id="{834f9170-b270-620b-8600-93e2a19c4c55}">
           <p14:sldIdLst>
             <p14:sldId id="291"/>
             <p14:sldId id="292"/>
@@ -232,7 +232,7 @@
             <p14:sldId id="307"/>
           </p14:sldIdLst>
         </p14:section>
-        <p14:section name="정리와 예고" id="{3204447f-09c6-d0ad-d17a-560ea3377d20}">
+        <p14:section name="정리와 예고" id="{872ffcc9-e452-a407-c38d-b971bbb47ad7}">
           <p14:sldIdLst>
             <p14:sldId id="308"/>
             <p14:sldId id="309"/>
@@ -54292,47 +54292,47 @@
 </file>
 
 <file path=ppt/theme/theme1.xml><?xml version="1.0" encoding="utf-8"?>
-<a:theme xmlns:a="http://schemas.openxmlformats.org/drawingml/2006/main" name="Office Theme">
+<a:theme xmlns:a="http://schemas.openxmlformats.org/drawingml/2006/main" name="WLC Teal">
   <a:themeElements>
-    <a:clrScheme name="Office">
+    <a:clrScheme name="WLC Teal">
       <a:dk1>
-        <a:sysClr val="windowText" lastClr="000000"/>
+        <a:srgbClr val="222222"/>
       </a:dk1>
       <a:lt1>
-        <a:sysClr val="window" lastClr="FFFFFF"/>
+        <a:srgbClr val="FFFFFF"/>
       </a:lt1>
       <a:dk2>
-        <a:srgbClr val="44546A"/>
+        <a:srgbClr val="1F4E4A"/>
       </a:dk2>
       <a:lt2>
-        <a:srgbClr val="E7E6E6"/>
+        <a:srgbClr val="EAF3F0"/>
       </a:lt2>
       <a:accent1>
-        <a:srgbClr val="4472C4"/>
+        <a:srgbClr val="2E7D6B"/>
       </a:accent1>
       <a:accent2>
-        <a:srgbClr val="ED7D31"/>
+        <a:srgbClr val="D98E04"/>
       </a:accent2>
       <a:accent3>
-        <a:srgbClr val="A5A5A5"/>
+        <a:srgbClr val="3A6EA5"/>
       </a:accent3>
       <a:accent4>
-        <a:srgbClr val="FFC000"/>
+        <a:srgbClr val="B5452F"/>
       </a:accent4>
       <a:accent5>
-        <a:srgbClr val="5B9BD5"/>
+        <a:srgbClr val="8FB9A8"/>
       </a:accent5>
       <a:accent6>
-        <a:srgbClr val="70AD47"/>
+        <a:srgbClr val="6B6B6B"/>
       </a:accent6>
       <a:hlink>
-        <a:srgbClr val="0563C1"/>
+        <a:srgbClr val="3A6EA5"/>
       </a:hlink>
       <a:folHlink>
-        <a:srgbClr val="954F72"/>
+        <a:srgbClr val="1F4E4A"/>
       </a:folHlink>
     </a:clrScheme>
-    <a:fontScheme name="Office">
+    <a:fontScheme name="WLC Teal">
       <a:majorFont>
         <a:latin typeface="Noto Serif KR Black"/>
         <a:ea typeface=""/>

</xml_diff>